<commit_message>
results: finalize corrected evaluation and deliverables
</commit_message>
<xml_diff>
--- a/presentation/FDL_Speech_Commands.pptx
+++ b/presentation/FDL_Speech_Commands.pptx
@@ -2,27 +2,27 @@
 <file path=ppt/presentation.xml><?xml version="1.0" encoding="utf-8"?>
 <p:presentation xmlns:p="http://schemas.openxmlformats.org/presentationml/2006/main">
   <p:sldMasterIdLst>
-    <p:sldMasterId xmlns:r="http://schemas.openxmlformats.org/officeDocument/2006/relationships" id="2147483648" r:id="Rf9dbd2527ad54ece"/>
+    <p:sldMasterId xmlns:r="http://schemas.openxmlformats.org/officeDocument/2006/relationships" id="2147483648" r:id="R6e1e46ed0e044705"/>
   </p:sldMasterIdLst>
   <p:notesMasterIdLst>
-    <p:notesMasterId xmlns:r="http://schemas.openxmlformats.org/officeDocument/2006/relationships" r:id="Rac69c6c2667c4be3"/>
+    <p:notesMasterId xmlns:r="http://schemas.openxmlformats.org/officeDocument/2006/relationships" r:id="R00c12bbe653946a4"/>
   </p:notesMasterIdLst>
   <p:sldIdLst>
-    <p:sldId xmlns:r="http://schemas.openxmlformats.org/officeDocument/2006/relationships" id="256" r:id="R825a6cdb76ab4846"/>
-    <p:sldId xmlns:r="http://schemas.openxmlformats.org/officeDocument/2006/relationships" id="257" r:id="Rf45a10811f874780"/>
-    <p:sldId xmlns:r="http://schemas.openxmlformats.org/officeDocument/2006/relationships" id="258" r:id="R28ef78df8e454623"/>
-    <p:sldId xmlns:r="http://schemas.openxmlformats.org/officeDocument/2006/relationships" id="259" r:id="R030f16bf41e54e65"/>
-    <p:sldId xmlns:r="http://schemas.openxmlformats.org/officeDocument/2006/relationships" id="260" r:id="R78b4339c4d1547e7"/>
-    <p:sldId xmlns:r="http://schemas.openxmlformats.org/officeDocument/2006/relationships" id="261" r:id="R2bc1c0177947481a"/>
-    <p:sldId xmlns:r="http://schemas.openxmlformats.org/officeDocument/2006/relationships" id="262" r:id="Rdba2826eaf124d7f"/>
-    <p:sldId xmlns:r="http://schemas.openxmlformats.org/officeDocument/2006/relationships" id="263" r:id="R2a93b38393174d5d"/>
-    <p:sldId xmlns:r="http://schemas.openxmlformats.org/officeDocument/2006/relationships" id="264" r:id="R81664e67ff1d4743"/>
-    <p:sldId xmlns:r="http://schemas.openxmlformats.org/officeDocument/2006/relationships" id="265" r:id="R87e3af6094d64bc2"/>
-    <p:sldId xmlns:r="http://schemas.openxmlformats.org/officeDocument/2006/relationships" id="266" r:id="Rbc85ce5de46b4422"/>
-    <p:sldId xmlns:r="http://schemas.openxmlformats.org/officeDocument/2006/relationships" id="267" r:id="R5355ea6132744ffa"/>
-    <p:sldId xmlns:r="http://schemas.openxmlformats.org/officeDocument/2006/relationships" id="268" r:id="R66bc6a632f664024"/>
-    <p:sldId xmlns:r="http://schemas.openxmlformats.org/officeDocument/2006/relationships" id="269" r:id="Rf5a6510073064ad8"/>
-    <p:sldId xmlns:r="http://schemas.openxmlformats.org/officeDocument/2006/relationships" id="270" r:id="Rb395555bc20c47d7"/>
+    <p:sldId xmlns:r="http://schemas.openxmlformats.org/officeDocument/2006/relationships" id="256" r:id="R20e97837912c4476"/>
+    <p:sldId xmlns:r="http://schemas.openxmlformats.org/officeDocument/2006/relationships" id="257" r:id="R0a13a1bd606b4000"/>
+    <p:sldId xmlns:r="http://schemas.openxmlformats.org/officeDocument/2006/relationships" id="258" r:id="R912122a038014eb8"/>
+    <p:sldId xmlns:r="http://schemas.openxmlformats.org/officeDocument/2006/relationships" id="259" r:id="Rae06a53c3f0d4078"/>
+    <p:sldId xmlns:r="http://schemas.openxmlformats.org/officeDocument/2006/relationships" id="260" r:id="R34ddeb49ebb9479d"/>
+    <p:sldId xmlns:r="http://schemas.openxmlformats.org/officeDocument/2006/relationships" id="261" r:id="Rd968a26a86704715"/>
+    <p:sldId xmlns:r="http://schemas.openxmlformats.org/officeDocument/2006/relationships" id="262" r:id="Rca7a804fb5a94b04"/>
+    <p:sldId xmlns:r="http://schemas.openxmlformats.org/officeDocument/2006/relationships" id="263" r:id="Rd3ff13df1e0f431b"/>
+    <p:sldId xmlns:r="http://schemas.openxmlformats.org/officeDocument/2006/relationships" id="264" r:id="Ra818e8393b9e4adf"/>
+    <p:sldId xmlns:r="http://schemas.openxmlformats.org/officeDocument/2006/relationships" id="265" r:id="R0034871587e44e01"/>
+    <p:sldId xmlns:r="http://schemas.openxmlformats.org/officeDocument/2006/relationships" id="266" r:id="Rb2b064e62e97459c"/>
+    <p:sldId xmlns:r="http://schemas.openxmlformats.org/officeDocument/2006/relationships" id="267" r:id="R6e45e4b7cf9f4b51"/>
+    <p:sldId xmlns:r="http://schemas.openxmlformats.org/officeDocument/2006/relationships" id="268" r:id="R2c78f25fbd8b4449"/>
+    <p:sldId xmlns:r="http://schemas.openxmlformats.org/officeDocument/2006/relationships" id="269" r:id="R0bdc6425e3ac4360"/>
+    <p:sldId xmlns:r="http://schemas.openxmlformats.org/officeDocument/2006/relationships" id="270" r:id="Re286c1f428324bce"/>
   </p:sldIdLst>
   <p:sldSz cx="12192000" cy="6858000"/>
   <p:notesSz cx="6858000" cy="9144000"/>
@@ -551,7 +551,7 @@
           <a:lstStyle xmlns:a="http://schemas.openxmlformats.org/drawingml/2006/main"/>
           <a:p xmlns:a="http://schemas.openxmlformats.org/drawingml/2006/main">
             <a:r>
-              <a:t>The CRNN reaches 0.9427 validation macro-F1, about one point above the clean DS-CNN. The margin is meaningful but not free: the final model is 6.24 times larger. The ranking also shows that augmentation is not automatically beneficial on the compact architecture.</a:t>
+              <a:t>The corrected CRNN reaches 0.9399 validation macro-F1, 0.76 percentage points above the clean DS-CNN. The margin is not free: the final model is 6.24 times larger. The strict E03-to-E04 comparison also shows that augmentation trades some clean validation score for robustness.</a:t>
             </a:r>
           </a:p>
           <a:p xmlns:a="http://schemas.openxmlformats.org/drawingml/2006/main">
@@ -646,7 +646,7 @@
           <a:lstStyle xmlns:a="http://schemas.openxmlformats.org/drawingml/2006/main"/>
           <a:p xmlns:a="http://schemas.openxmlformats.org/drawingml/2006/main">
             <a:r>
-              <a:t>This is our most useful failed expectation. Adding the full waveform and SpecAugment recipe to the DS-CNN lowers clean macro-F1 by 2.74 points. Under an extreme 0 dB stress test, however, the same recipe improves macro-F1 by 52.35 points. The CRNN combines the best clean score with the strongest curve.</a:t>
+              <a:t>E03 and E04 now differ only in augmentation, making this a strict ablation. Augmentation lowers clean validation macro-F1 by 2.29 points but improves the extreme zero-decibel result by 50.20 points. The background corruption bank is split-aware, so these validation curves do not reuse the training region.</a:t>
             </a:r>
           </a:p>
           <a:p xmlns:a="http://schemas.openxmlformats.org/drawingml/2006/main">
@@ -746,7 +746,7 @@
           <a:lstStyle xmlns:a="http://schemas.openxmlformats.org/drawingml/2006/main"/>
           <a:p xmlns:a="http://schemas.openxmlformats.org/drawingml/2006/main">
             <a:r>
-              <a:t>After freezing the selected model, we evaluated the official test split once. Accuracy is 94.19 percent and macro-F1 is 0.9421. Ten-thousand stratified bootstrap samples give tight uncertainty intervals. The validation-to-test change is only minus 0.06 points.</a:t>
+              <a:t>After the corrected protocol and frozen selection, the official test split was evaluated. Accuracy is 93.12 percent and macro-F1 is 0.9315. Ten-thousand stratified bootstrap samples give a macro-F1 interval from 0.9228 to 0.9402. The validation-to-test change is minus 0.85 percentage points.</a:t>
             </a:r>
           </a:p>
           <a:p xmlns:a="http://schemas.openxmlformats.org/drawingml/2006/main">
@@ -846,7 +846,7 @@
           <a:lstStyle xmlns:a="http://schemas.openxmlformats.org/drawingml/2006/main"/>
           <a:p xmlns:a="http://schemas.openxmlformats.org/drawingml/2006/main">
             <a:r>
-              <a:t>Temporal shifts of plus or minus 100 milliseconds cost at most 0.34 macro-F1 points. Background noise is the harder axis: 0 dB drops the score by 12.75 points. Calibration is good in aggregate, and compiled feature extraction plus inference takes a 3.41 millisecond median on the recorded CPU machine.</a:t>
+              <a:t>Temporal shifts of plus or minus 100 milliseconds cost at most 0.38 macro-F1 points. Background noise is the harder axis: zero decibels lowers macro-F1 by 11.16 points. Expected calibration error is 0.0303, and compiled feature extraction plus inference takes a 3.33 millisecond median on the recorded CPU machine.</a:t>
             </a:r>
           </a:p>
           <a:p xmlns:a="http://schemas.openxmlformats.org/drawingml/2006/main">
@@ -946,7 +946,7 @@
           <a:lstStyle xmlns:a="http://schemas.openxmlformats.org/drawingml/2006/main"/>
           <a:p xmlns:a="http://schemas.openxmlformats.org/drawingml/2006/main">
             <a:r>
-              <a:t>Quantitative averages hide rare but important failures. Unknown is the weakest class, and down-to-no is the most common directed confusion. All six most confident errors exceed 0.998 confidence, so low ECE does not mean the model is never overconfident. We export every shown clip as a playable WAV for listening during discussion.</a:t>
+              <a:t>Quantitative averages hide rare but important failures. Unknown is the weakest class at 0.840 F1, while silence-to-up is the most common directed confusion with 17 clips. All six most confident errors round to at least 0.998 confidence, so an aggregate ECE near three percent does not mean the model is never overconfident. Every exported example has a playable WAV.</a:t>
             </a:r>
           </a:p>
           <a:p xmlns:a="http://schemas.openxmlformats.org/drawingml/2006/main">
@@ -1046,7 +1046,7 @@
           <a:lstStyle xmlns:a="http://schemas.openxmlformats.org/drawingml/2006/main"/>
           <a:p xmlns:a="http://schemas.openxmlformats.org/drawingml/2006/main">
             <a:r>
-              <a:t>Our conclusion has three parts. First, preserving time-frequency structure and modeling temporal context produces the best score. Second, the compact DS-CNN is a valid alternative when footprint dominates. Third, a strong average does not erase noise sensitivity or rare confident errors. The complete repository reproduces every claim and supports a live inference demo.</a:t>
+              <a:t>Our conclusion has three parts. First, preserving time-frequency structure and modeling temporal context produces the best corrected score: 0.9315 test macro-F1. Second, the compact DS-CNN remains a valid alternative when footprint dominates. Third, a strong average does not erase noise sensitivity, unknown speech, or rare confident errors. The repository reproduces every claim and supports a live inference demo.</a:t>
             </a:r>
           </a:p>
           <a:p xmlns:a="http://schemas.openxmlformats.org/drawingml/2006/main">
@@ -1146,7 +1146,7 @@
           <a:lstStyle xmlns:a="http://schemas.openxmlformats.org/drawingml/2006/main"/>
           <a:p xmlns:a="http://schemas.openxmlformats.org/drawingml/2006/main">
             <a:r>
-              <a:t>The task is 12-way classification. Ten labels are actionable words; unknown catches non-target speech; silence rejects background audio. We intentionally avoid pretrained encoders so that every learned representation above the log-Mel front end is ours.</a:t>
+              <a:t>The task is 12-way classification. Ten labels are actionable words; unknown catches non-target speech; silence rejects background audio. The modeled dataset is near-balanced rather than exactly balanced, and we intentionally avoid pretrained encoders.</a:t>
             </a:r>
           </a:p>
           <a:p xmlns:a="http://schemas.openxmlformats.org/drawingml/2006/main">
@@ -1241,7 +1241,7 @@
           <a:lstStyle xmlns:a="http://schemas.openxmlformats.org/drawingml/2006/main"/>
           <a:p xmlns:a="http://schemas.openxmlformats.org/drawingml/2006/main">
             <a:r>
-              <a:t>The release contains 30 spoken words, but the professor-defined task uses 12 modeled classes. We preserve all non-target words as candidates for unknown rather than deleting them. The deterministic manifest gives us a balanced problem while remaining reproducible.</a:t>
+              <a:t>The release contains 30 spoken words, but the professor-defined task uses 12 modeled classes. Every target recording is retained. Unknown is sampled deterministically from non-target words and silence is constructed from reserved background regions, producing an approximately balanced, reproducible manifest.</a:t>
             </a:r>
           </a:p>
           <a:p xmlns:a="http://schemas.openxmlformats.org/drawingml/2006/main">
@@ -1436,7 +1436,7 @@
           <a:lstStyle xmlns:a="http://schemas.openxmlformats.org/drawingml/2006/main"/>
           <a:p xmlns:a="http://schemas.openxmlformats.org/drawingml/2006/main">
             <a:r>
-              <a:t>Leakage is the biggest silent risk in small audio datasets. We validate that no speaker appears in more than one split. For synthetic silence, the manifest also reserves disjoint temporal regions of each background recording. Any violation aborts preparation.</a:t>
+              <a:t>Leakage is the biggest silent risk in audio. Official lists keep speakers disjoint. Synthetic silence uses non-overlapping temporal regions, and background recordings used for augmentation or robustness are reserved by time: the first 80 percent for training, the next 10 for validation, and the final 10 for testing. Automated guards fail on speaker overlap.</a:t>
             </a:r>
           </a:p>
           <a:p xmlns:a="http://schemas.openxmlformats.org/drawingml/2006/main">
@@ -1456,12 +1456,12 @@
           </a:p>
           <a:p xmlns:a="http://schemas.openxmlformats.org/drawingml/2006/main">
             <a:r>
+              <a:t>- Repository noise partition: src/fdl_speech_commands/audio.py</a:t>
+            </a:r>
+          </a:p>
+          <a:p xmlns:a="http://schemas.openxmlformats.org/drawingml/2006/main">
+            <a:r>
               <a:t>- Repository tests: tests/test_data_protocol.py</a:t>
-            </a:r>
-          </a:p>
-          <a:p xmlns:a="http://schemas.openxmlformats.org/drawingml/2006/main">
-            <a:r>
-              <a:t>- Repository counts: artifacts/tables/modeling_split_counts.csv</a:t>
             </a:r>
           </a:p>
           <a:p xmlns:a="http://schemas.openxmlformats.org/drawingml/2006/main">
@@ -1536,7 +1536,7 @@
           <a:lstStyle xmlns:a="http://schemas.openxmlformats.org/drawingml/2006/main"/>
           <a:p xmlns:a="http://schemas.openxmlformats.org/drawingml/2006/main">
             <a:r>
-              <a:t>We first standardize duration, then compute a short-time Fourier transform. Forty Mel filters compress frequency on a perceptual scale, and the logarithm stabilizes amplitude. The resulting map stays two-dimensional, so convolution can exploit local patterns; the recurrent layer later integrates time.</a:t>
+              <a:t>We standardize each clip to 16,000 samples, then apply a 30 millisecond Hann-window STFT with a 10 millisecond stride. Forty Mel filters compress frequency and the logarithm stabilizes amplitude. With no end padding, the implemented neural input is a 40 by 98 map normalized using training statistics only.</a:t>
             </a:r>
           </a:p>
           <a:p xmlns:a="http://schemas.openxmlformats.org/drawingml/2006/main">
@@ -1821,7 +1821,7 @@
           <a:lstStyle xmlns:a="http://schemas.openxmlformats.org/drawingml/2006/main"/>
           <a:p xmlns:a="http://schemas.openxmlformats.org/drawingml/2006/main">
             <a:r>
-              <a:t>All five runs use early stopping and the same data protocol. We rank them on validation macro-F1, promote the winner, and only then repeat that configuration on two additional seeds. The final seed-42 model remains frozen; repeats establish stability, not a new search.</a:t>
+              <a:t>All five corrected runs use early stopping and the same data protocol. We rank on validation macro-F1 and then repeat the winner on two additional seeds. A protocol audit invalidated earlier artifacts because E04 was not a strict ablation and background noise was not split-aware; those artifacts were superseded, all affected models were retrained, and the corrected seed-42 model was frozen before the final evaluation.</a:t>
             </a:r>
           </a:p>
           <a:p xmlns:a="http://schemas.openxmlformats.org/drawingml/2006/main">
@@ -1836,7 +1836,7 @@
           </a:p>
           <a:p xmlns:a="http://schemas.openxmlformats.org/drawingml/2006/main">
             <a:r>
-              <a:t>- Repository training implementation: src/fdl_speech_commands/training.py</a:t>
+              <a:t>- Repository protocol revision: docs/experiment_protocol.md</a:t>
             </a:r>
           </a:p>
           <a:p xmlns:a="http://schemas.openxmlformats.org/drawingml/2006/main">
@@ -1919,7 +1919,7 @@
   </p:cSld>
   <p:clrMap bg1="lt1" tx1="dk1" bg2="lt2" tx2="dk2" accent1="accent1" accent2="accent2" accent3="accent3" accent4="accent4" accent5="accent5" accent6="accent6" hlink="hlink" folHlink="folHlink"/>
   <p:sldLayoutIdLst>
-    <p:sldLayoutId xmlns:r="http://schemas.openxmlformats.org/officeDocument/2006/relationships" id="2147483649" r:id="R02cf9f47d61f4bf7"/>
+    <p:sldLayoutId xmlns:r="http://schemas.openxmlformats.org/officeDocument/2006/relationships" id="2147483649" r:id="R695482d191eb44aa"/>
   </p:sldLayoutIdLst>
   <p:txStyles>
     <p:titleStyle>
@@ -2542,13 +2542,13 @@
                 <c:v>0.8759</c:v>
               </c:pt>
               <c:pt idx="2">
-                <c:v>0.905</c:v>
+                <c:v>0.9095</c:v>
               </c:pt>
               <c:pt idx="3">
                 <c:v>0.9324</c:v>
               </c:pt>
               <c:pt idx="4">
-                <c:v>0.9427</c:v>
+                <c:v>0.9399</c:v>
               </c:pt>
             </c:numLit>
           </c:val>
@@ -2676,6 +2676,7 @@
     <c:plotArea>
       <c:lineChart>
         <c:grouping val="standard"/>
+        <c:varyColors val="0"/>
         <c:ser>
           <c:idx val="0"/>
           <c:order val="0"/>
@@ -2724,13 +2725,13 @@
                 <c:v>0.9324</c:v>
               </c:pt>
               <c:pt idx="1">
-                <c:v>0.8642</c:v>
+                <c:v>0.8644</c:v>
               </c:pt>
               <c:pt idx="2">
-                <c:v>0.6754</c:v>
+                <c:v>0.6855</c:v>
               </c:pt>
               <c:pt idx="3">
-                <c:v>0.166</c:v>
+                <c:v>0.2093</c:v>
               </c:pt>
             </c:numLit>
           </c:val>
@@ -2780,16 +2781,16 @@
               <c:formatCode>General</c:formatCode>
               <c:ptCount val="4"/>
               <c:pt idx="0">
-                <c:v>0.905</c:v>
+                <c:v>0.9095</c:v>
               </c:pt>
               <c:pt idx="1">
-                <c:v>0.9003</c:v>
+                <c:v>0.8991</c:v>
               </c:pt>
               <c:pt idx="2">
-                <c:v>0.8692</c:v>
+                <c:v>0.8664</c:v>
               </c:pt>
               <c:pt idx="3">
-                <c:v>0.6895</c:v>
+                <c:v>0.7112</c:v>
               </c:pt>
             </c:numLit>
           </c:val>
@@ -2839,16 +2840,16 @@
               <c:formatCode>General</c:formatCode>
               <c:ptCount val="4"/>
               <c:pt idx="0">
-                <c:v>0.9427</c:v>
+                <c:v>0.9399</c:v>
               </c:pt>
               <c:pt idx="1">
-                <c:v>0.9337</c:v>
+                <c:v>0.9292</c:v>
               </c:pt>
               <c:pt idx="2">
-                <c:v>0.9078</c:v>
+                <c:v>0.9015</c:v>
               </c:pt>
               <c:pt idx="3">
-                <c:v>0.7929</c:v>
+                <c:v>0.7841</c:v>
               </c:pt>
             </c:numLit>
           </c:val>
@@ -2987,6 +2988,7 @@
     <c:plotArea>
       <c:lineChart>
         <c:grouping val="standard"/>
+        <c:varyColors val="0"/>
         <c:ser>
           <c:idx val="0"/>
           <c:order val="0"/>
@@ -3032,16 +3034,16 @@
               <c:formatCode>General</c:formatCode>
               <c:ptCount val="4"/>
               <c:pt idx="0">
-                <c:v>0.9421</c:v>
+                <c:v>0.9315</c:v>
               </c:pt>
               <c:pt idx="1">
-                <c:v>0.9308</c:v>
+                <c:v>0.9246</c:v>
               </c:pt>
               <c:pt idx="2">
-                <c:v>0.9096</c:v>
+                <c:v>0.9106</c:v>
               </c:pt>
               <c:pt idx="3">
-                <c:v>0.8146</c:v>
+                <c:v>0.8199</c:v>
               </c:pt>
             </c:numLit>
           </c:val>
@@ -3217,6 +3219,7 @@
           <a:lstStyle xmlns:a="http://schemas.openxmlformats.org/drawingml/2006/main"/>
           <a:p xmlns:a="http://schemas.openxmlformats.org/drawingml/2006/main">
             <a:pPr algn="l">
+              <a:buNone/>
               <a:defRPr sz="1350" b="1">
                 <a:solidFill>
                   <a:srgbClr val="59616B"/>
@@ -3273,6 +3276,7 @@
           <a:lstStyle xmlns:a="http://schemas.openxmlformats.org/drawingml/2006/main"/>
           <a:p xmlns:a="http://schemas.openxmlformats.org/drawingml/2006/main">
             <a:pPr algn="l">
+              <a:buNone/>
               <a:defRPr sz="4950" b="1">
                 <a:solidFill>
                   <a:srgbClr val="000000"/>
@@ -3296,6 +3300,7 @@
           </a:p>
           <a:p xmlns:a="http://schemas.openxmlformats.org/drawingml/2006/main">
             <a:pPr algn="l">
+              <a:buNone/>
               <a:defRPr sz="4950" b="1">
                 <a:solidFill>
                   <a:srgbClr val="000000"/>
@@ -3352,6 +3357,7 @@
           <a:lstStyle xmlns:a="http://schemas.openxmlformats.org/drawingml/2006/main"/>
           <a:p xmlns:a="http://schemas.openxmlformats.org/drawingml/2006/main">
             <a:pPr algn="l">
+              <a:buNone/>
               <a:defRPr sz="2400" b="0">
                 <a:solidFill>
                   <a:srgbClr val="59616B"/>
@@ -3408,6 +3414,7 @@
           <a:lstStyle xmlns:a="http://schemas.openxmlformats.org/drawingml/2006/main"/>
           <a:p xmlns:a="http://schemas.openxmlformats.org/drawingml/2006/main">
             <a:pPr algn="l">
+              <a:buNone/>
               <a:defRPr sz="1650" b="1">
                 <a:solidFill>
                   <a:srgbClr val="000000"/>
@@ -3464,6 +3471,7 @@
           <a:lstStyle xmlns:a="http://schemas.openxmlformats.org/drawingml/2006/main"/>
           <a:p xmlns:a="http://schemas.openxmlformats.org/drawingml/2006/main">
             <a:pPr algn="l">
+              <a:buNone/>
               <a:defRPr sz="1350" b="0">
                 <a:solidFill>
                   <a:srgbClr val="59616B"/>
@@ -3522,14 +3530,14 @@
       </p:sp>
       <p:pic>
         <p:nvPicPr>
-          <p:cNvPr id="15" name=""/>
+          <p:cNvPr id="17" name=""/>
           <p:cNvPicPr>
             <a:picLocks xmlns:a="http://schemas.openxmlformats.org/drawingml/2006/main" noChangeAspect="1"/>
           </p:cNvPicPr>
           <p:nvPr/>
         </p:nvPicPr>
         <p:blipFill>
-          <a:blip xmlns:r="http://schemas.openxmlformats.org/officeDocument/2006/relationships" xmlns:a="http://schemas.openxmlformats.org/drawingml/2006/main" r:embed="R67b038a164124288"/>
+          <a:blip xmlns:r="http://schemas.openxmlformats.org/officeDocument/2006/relationships" xmlns:a="http://schemas.openxmlformats.org/drawingml/2006/main" r:embed="R81345f88880d4479"/>
           <a:stretch xmlns:a="http://schemas.openxmlformats.org/drawingml/2006/main"/>
         </p:blipFill>
         <p:spPr>
@@ -3575,6 +3583,7 @@
           <a:lstStyle xmlns:a="http://schemas.openxmlformats.org/drawingml/2006/main"/>
           <a:p xmlns:a="http://schemas.openxmlformats.org/drawingml/2006/main">
             <a:pPr algn="r">
+              <a:buNone/>
               <a:defRPr sz="1050" b="0">
                 <a:solidFill>
                   <a:srgbClr val="59616B"/>
@@ -3660,6 +3669,7 @@
           <a:lstStyle xmlns:a="http://schemas.openxmlformats.org/drawingml/2006/main"/>
           <a:p xmlns:a="http://schemas.openxmlformats.org/drawingml/2006/main">
             <a:pPr algn="l">
+              <a:buNone/>
               <a:defRPr sz="1200" b="1">
                 <a:solidFill>
                   <a:srgbClr val="59616B"/>
@@ -3716,6 +3726,7 @@
           <a:lstStyle xmlns:a="http://schemas.openxmlformats.org/drawingml/2006/main"/>
           <a:p xmlns:a="http://schemas.openxmlformats.org/drawingml/2006/main">
             <a:pPr algn="l">
+              <a:buNone/>
               <a:defRPr sz="3600" b="1">
                 <a:solidFill>
                   <a:srgbClr val="000000"/>
@@ -3734,7 +3745,7 @@
                 <a:ea typeface="Arial"/>
                 <a:cs typeface="Arial"/>
               </a:rPr>
-              <a:t>The CRNN wins validation by one macro-F1 point</a:t>
+              <a:t>CRNN leads validation; DS-CNN stays compact</a:t>
             </a:r>
           </a:p>
         </p:txBody>
@@ -3772,6 +3783,7 @@
           <a:lstStyle xmlns:a="http://schemas.openxmlformats.org/drawingml/2006/main"/>
           <a:p xmlns:a="http://schemas.openxmlformats.org/drawingml/2006/main">
             <a:pPr algn="r">
+              <a:buNone/>
               <a:defRPr sz="1050" b="0">
                 <a:solidFill>
                   <a:srgbClr val="59616B"/>
@@ -3797,7 +3809,7 @@
       </p:sp>
       <p:graphicFrame>
         <p:nvGraphicFramePr>
-          <p:cNvPr id="17" name="Chart"/>
+          <p:cNvPr id="19" name="Chart"/>
           <p:cNvGraphicFramePr/>
           <p:nvPr/>
         </p:nvGraphicFramePr>
@@ -3807,7 +3819,7 @@
         </p:xfrm>
         <a:graphic xmlns:a="http://schemas.openxmlformats.org/drawingml/2006/main">
           <a:graphicData uri="http://schemas.openxmlformats.org/drawingml/2006/chart">
-            <c:chart xmlns:r="http://schemas.openxmlformats.org/officeDocument/2006/relationships" xmlns:c="http://schemas.openxmlformats.org/drawingml/2006/chart" r:id="R8c2272b1b3354321"/>
+            <c:chart xmlns:r="http://schemas.openxmlformats.org/officeDocument/2006/relationships" xmlns:c="http://schemas.openxmlformats.org/drawingml/2006/chart" r:id="R942614dccdad4d69"/>
           </a:graphicData>
         </a:graphic>
       </p:graphicFrame>
@@ -3844,6 +3856,7 @@
           <a:lstStyle xmlns:a="http://schemas.openxmlformats.org/drawingml/2006/main"/>
           <a:p xmlns:a="http://schemas.openxmlformats.org/drawingml/2006/main">
             <a:pPr algn="r">
+              <a:buNone/>
               <a:defRPr sz="1350" b="1">
                 <a:solidFill>
                   <a:srgbClr val="000000"/>
@@ -3862,7 +3875,7 @@
                 <a:ea typeface="Arial"/>
                 <a:cs typeface="Arial"/>
               </a:rPr>
-              <a:t>0.9427</a:t>
+              <a:t>0.9399</a:t>
             </a:r>
           </a:p>
         </p:txBody>
@@ -3900,6 +3913,7 @@
           <a:lstStyle xmlns:a="http://schemas.openxmlformats.org/drawingml/2006/main"/>
           <a:p xmlns:a="http://schemas.openxmlformats.org/drawingml/2006/main">
             <a:pPr algn="r">
+              <a:buNone/>
               <a:defRPr sz="1350" b="1">
                 <a:solidFill>
                   <a:srgbClr val="000000"/>
@@ -3956,6 +3970,7 @@
           <a:lstStyle xmlns:a="http://schemas.openxmlformats.org/drawingml/2006/main"/>
           <a:p xmlns:a="http://schemas.openxmlformats.org/drawingml/2006/main">
             <a:pPr algn="r">
+              <a:buNone/>
               <a:defRPr sz="1350" b="1">
                 <a:solidFill>
                   <a:srgbClr val="000000"/>
@@ -3974,7 +3989,7 @@
                 <a:ea typeface="Arial"/>
                 <a:cs typeface="Arial"/>
               </a:rPr>
-              <a:t>0.9050</a:t>
+              <a:t>0.9095</a:t>
             </a:r>
           </a:p>
         </p:txBody>
@@ -4012,6 +4027,7 @@
           <a:lstStyle xmlns:a="http://schemas.openxmlformats.org/drawingml/2006/main"/>
           <a:p xmlns:a="http://schemas.openxmlformats.org/drawingml/2006/main">
             <a:pPr algn="r">
+              <a:buNone/>
               <a:defRPr sz="1350" b="1">
                 <a:solidFill>
                   <a:srgbClr val="000000"/>
@@ -4068,6 +4084,7 @@
           <a:lstStyle xmlns:a="http://schemas.openxmlformats.org/drawingml/2006/main"/>
           <a:p xmlns:a="http://schemas.openxmlformats.org/drawingml/2006/main">
             <a:pPr algn="r">
+              <a:buNone/>
               <a:defRPr sz="1350" b="1">
                 <a:solidFill>
                   <a:srgbClr val="000000"/>
@@ -4157,6 +4174,7 @@
           <a:lstStyle xmlns:a="http://schemas.openxmlformats.org/drawingml/2006/main"/>
           <a:p xmlns:a="http://schemas.openxmlformats.org/drawingml/2006/main">
             <a:pPr algn="l">
+              <a:buNone/>
               <a:defRPr sz="4200" b="1">
                 <a:solidFill>
                   <a:srgbClr val="3D8DFF"/>
@@ -4175,7 +4193,7 @@
                 <a:ea typeface="Arial"/>
                 <a:cs typeface="Arial"/>
               </a:rPr>
-              <a:t>0.9427</a:t>
+              <a:t>0.9399</a:t>
             </a:r>
           </a:p>
         </p:txBody>
@@ -4213,6 +4231,7 @@
           <a:lstStyle xmlns:a="http://schemas.openxmlformats.org/drawingml/2006/main"/>
           <a:p xmlns:a="http://schemas.openxmlformats.org/drawingml/2006/main">
             <a:pPr algn="l">
+              <a:buNone/>
               <a:defRPr sz="1725" b="1">
                 <a:solidFill>
                   <a:srgbClr val="000000"/>
@@ -4269,6 +4288,7 @@
           <a:lstStyle xmlns:a="http://schemas.openxmlformats.org/drawingml/2006/main"/>
           <a:p xmlns:a="http://schemas.openxmlformats.org/drawingml/2006/main">
             <a:pPr algn="l">
+              <a:buNone/>
               <a:defRPr sz="1650" b="0">
                 <a:solidFill>
                   <a:srgbClr val="59616B"/>
@@ -4287,11 +4307,12 @@
                 <a:ea typeface="Arial"/>
                 <a:cs typeface="Arial"/>
               </a:rPr>
-              <a:t>+1.03 points over clean DS-CNN</a:t>
+              <a:t>+0.76 points over clean DS-CNN</a:t>
             </a:r>
           </a:p>
           <a:p xmlns:a="http://schemas.openxmlformats.org/drawingml/2006/main">
             <a:pPr algn="l">
+              <a:buNone/>
               <a:defRPr sz="1650" b="0">
                 <a:solidFill>
                   <a:srgbClr val="59616B"/>
@@ -4377,6 +4398,7 @@
           <a:lstStyle xmlns:a="http://schemas.openxmlformats.org/drawingml/2006/main"/>
           <a:p xmlns:a="http://schemas.openxmlformats.org/drawingml/2006/main">
             <a:pPr algn="l">
+              <a:buNone/>
               <a:defRPr sz="1200" b="1">
                 <a:solidFill>
                   <a:srgbClr val="59616B"/>
@@ -4433,6 +4455,7 @@
           <a:lstStyle xmlns:a="http://schemas.openxmlformats.org/drawingml/2006/main"/>
           <a:p xmlns:a="http://schemas.openxmlformats.org/drawingml/2006/main">
             <a:pPr algn="l">
+              <a:buNone/>
               <a:defRPr sz="3600" b="1">
                 <a:solidFill>
                   <a:srgbClr val="000000"/>
@@ -4489,6 +4512,7 @@
           <a:lstStyle xmlns:a="http://schemas.openxmlformats.org/drawingml/2006/main"/>
           <a:p xmlns:a="http://schemas.openxmlformats.org/drawingml/2006/main">
             <a:pPr algn="r">
+              <a:buNone/>
               <a:defRPr sz="1050" b="0">
                 <a:solidFill>
                   <a:srgbClr val="59616B"/>
@@ -4514,7 +4538,7 @@
       </p:sp>
       <p:graphicFrame>
         <p:nvGraphicFramePr>
-          <p:cNvPr id="16" name="Chart"/>
+          <p:cNvPr id="18" name="Chart"/>
           <p:cNvGraphicFramePr/>
           <p:nvPr/>
         </p:nvGraphicFramePr>
@@ -4524,7 +4548,7 @@
         </p:xfrm>
         <a:graphic xmlns:a="http://schemas.openxmlformats.org/drawingml/2006/main">
           <a:graphicData uri="http://schemas.openxmlformats.org/drawingml/2006/chart">
-            <c:chart xmlns:r="http://schemas.openxmlformats.org/officeDocument/2006/relationships" xmlns:c="http://schemas.openxmlformats.org/drawingml/2006/chart" r:id="Ra8fd5ae30a3c4c54"/>
+            <c:chart xmlns:r="http://schemas.openxmlformats.org/officeDocument/2006/relationships" xmlns:c="http://schemas.openxmlformats.org/drawingml/2006/chart" r:id="Rb817fed16d994214"/>
           </a:graphicData>
         </a:graphic>
       </p:graphicFrame>
@@ -4625,6 +4649,7 @@
           <a:lstStyle xmlns:a="http://schemas.openxmlformats.org/drawingml/2006/main"/>
           <a:p xmlns:a="http://schemas.openxmlformats.org/drawingml/2006/main">
             <a:pPr algn="l">
+              <a:buNone/>
               <a:defRPr sz="3900" b="1">
                 <a:solidFill>
                   <a:srgbClr val="000000"/>
@@ -4643,7 +4668,7 @@
                 <a:ea typeface="Arial"/>
                 <a:cs typeface="Arial"/>
               </a:rPr>
-              <a:t>-2.74 pt</a:t>
+              <a:t>-2.29 pt</a:t>
             </a:r>
           </a:p>
         </p:txBody>
@@ -4681,6 +4706,7 @@
           <a:lstStyle xmlns:a="http://schemas.openxmlformats.org/drawingml/2006/main"/>
           <a:p xmlns:a="http://schemas.openxmlformats.org/drawingml/2006/main">
             <a:pPr algn="l">
+              <a:buNone/>
               <a:defRPr sz="1650" b="0">
                 <a:solidFill>
                   <a:srgbClr val="59616B"/>
@@ -4801,6 +4827,7 @@
           <a:lstStyle xmlns:a="http://schemas.openxmlformats.org/drawingml/2006/main"/>
           <a:p xmlns:a="http://schemas.openxmlformats.org/drawingml/2006/main">
             <a:pPr algn="l">
+              <a:buNone/>
               <a:defRPr sz="3900" b="1">
                 <a:solidFill>
                   <a:srgbClr val="000000"/>
@@ -4819,7 +4846,7 @@
                 <a:ea typeface="Arial"/>
                 <a:cs typeface="Arial"/>
               </a:rPr>
-              <a:t>+52.35 pt</a:t>
+              <a:t>+50.20 pt</a:t>
             </a:r>
           </a:p>
         </p:txBody>
@@ -4857,6 +4884,7 @@
           <a:lstStyle xmlns:a="http://schemas.openxmlformats.org/drawingml/2006/main"/>
           <a:p xmlns:a="http://schemas.openxmlformats.org/drawingml/2006/main">
             <a:pPr algn="l">
+              <a:buNone/>
               <a:defRPr sz="1650" b="0">
                 <a:solidFill>
                   <a:srgbClr val="59616B"/>
@@ -4942,6 +4970,7 @@
           <a:lstStyle xmlns:a="http://schemas.openxmlformats.org/drawingml/2006/main"/>
           <a:p xmlns:a="http://schemas.openxmlformats.org/drawingml/2006/main">
             <a:pPr algn="l">
+              <a:buNone/>
               <a:defRPr sz="1200" b="1">
                 <a:solidFill>
                   <a:srgbClr val="59616B"/>
@@ -4998,6 +5027,7 @@
           <a:lstStyle xmlns:a="http://schemas.openxmlformats.org/drawingml/2006/main"/>
           <a:p xmlns:a="http://schemas.openxmlformats.org/drawingml/2006/main">
             <a:pPr algn="l">
+              <a:buNone/>
               <a:defRPr sz="3600" b="1">
                 <a:solidFill>
                   <a:srgbClr val="000000"/>
@@ -5054,6 +5084,7 @@
           <a:lstStyle xmlns:a="http://schemas.openxmlformats.org/drawingml/2006/main"/>
           <a:p xmlns:a="http://schemas.openxmlformats.org/drawingml/2006/main">
             <a:pPr algn="r">
+              <a:buNone/>
               <a:defRPr sz="1050" b="0">
                 <a:solidFill>
                   <a:srgbClr val="59616B"/>
@@ -5174,6 +5205,7 @@
           <a:lstStyle xmlns:a="http://schemas.openxmlformats.org/drawingml/2006/main"/>
           <a:p xmlns:a="http://schemas.openxmlformats.org/drawingml/2006/main">
             <a:pPr algn="l">
+              <a:buNone/>
               <a:defRPr sz="3900" b="1">
                 <a:solidFill>
                   <a:srgbClr val="000000"/>
@@ -5192,7 +5224,7 @@
                 <a:ea typeface="Arial"/>
                 <a:cs typeface="Arial"/>
               </a:rPr>
-              <a:t>94.19%</a:t>
+              <a:t>93.12%</a:t>
             </a:r>
           </a:p>
         </p:txBody>
@@ -5230,6 +5262,7 @@
           <a:lstStyle xmlns:a="http://schemas.openxmlformats.org/drawingml/2006/main"/>
           <a:p xmlns:a="http://schemas.openxmlformats.org/drawingml/2006/main">
             <a:pPr algn="l">
+              <a:buNone/>
               <a:defRPr sz="1650" b="0">
                 <a:solidFill>
                   <a:srgbClr val="59616B"/>
@@ -5253,6 +5286,7 @@
           </a:p>
           <a:p xmlns:a="http://schemas.openxmlformats.org/drawingml/2006/main">
             <a:pPr algn="l">
+              <a:buNone/>
               <a:defRPr sz="1650" b="0">
                 <a:solidFill>
                   <a:srgbClr val="59616B"/>
@@ -5271,7 +5305,7 @@
                 <a:ea typeface="Arial"/>
                 <a:cs typeface="Arial"/>
               </a:rPr>
-              <a:t>95% CI: 93.35-95.00</a:t>
+              <a:t>95% CI: 92.24-94.00</a:t>
             </a:r>
           </a:p>
         </p:txBody>
@@ -5373,6 +5407,7 @@
           <a:lstStyle xmlns:a="http://schemas.openxmlformats.org/drawingml/2006/main"/>
           <a:p xmlns:a="http://schemas.openxmlformats.org/drawingml/2006/main">
             <a:pPr algn="l">
+              <a:buNone/>
               <a:defRPr sz="3900" b="1">
                 <a:solidFill>
                   <a:srgbClr val="000000"/>
@@ -5391,7 +5426,7 @@
                 <a:ea typeface="Arial"/>
                 <a:cs typeface="Arial"/>
               </a:rPr>
-              <a:t>0.9421</a:t>
+              <a:t>0.9315</a:t>
             </a:r>
           </a:p>
         </p:txBody>
@@ -5429,6 +5464,7 @@
           <a:lstStyle xmlns:a="http://schemas.openxmlformats.org/drawingml/2006/main"/>
           <a:p xmlns:a="http://schemas.openxmlformats.org/drawingml/2006/main">
             <a:pPr algn="l">
+              <a:buNone/>
               <a:defRPr sz="1650" b="0">
                 <a:solidFill>
                   <a:srgbClr val="59616B"/>
@@ -5452,6 +5488,7 @@
           </a:p>
           <a:p xmlns:a="http://schemas.openxmlformats.org/drawingml/2006/main">
             <a:pPr algn="l">
+              <a:buNone/>
               <a:defRPr sz="1650" b="0">
                 <a:solidFill>
                   <a:srgbClr val="59616B"/>
@@ -5470,7 +5507,7 @@
                 <a:ea typeface="Arial"/>
                 <a:cs typeface="Arial"/>
               </a:rPr>
-              <a:t>95% CI: 0.9338-0.9501</a:t>
+              <a:t>95% CI: 0.9228-0.9402</a:t>
             </a:r>
           </a:p>
         </p:txBody>
@@ -5508,6 +5545,7 @@
           <a:lstStyle xmlns:a="http://schemas.openxmlformats.org/drawingml/2006/main"/>
           <a:p xmlns:a="http://schemas.openxmlformats.org/drawingml/2006/main">
             <a:pPr algn="l">
+              <a:buNone/>
               <a:defRPr sz="1650" b="1">
                 <a:solidFill>
                   <a:srgbClr val="2A9D3F"/>
@@ -5526,25 +5564,26 @@
                 <a:ea typeface="Arial"/>
                 <a:cs typeface="Arial"/>
               </a:rPr>
-              <a:t>Validation -&gt; test: -0.06 points</a:t>
+              <a:t>Validation -&gt; test: -0.85 points</a:t>
             </a:r>
           </a:p>
         </p:txBody>
       </p:sp>
       <p:pic>
         <p:nvPicPr>
-          <p:cNvPr id="26" name=""/>
+          <p:cNvPr id="28" name=""/>
           <p:cNvPicPr>
             <a:picLocks xmlns:a="http://schemas.openxmlformats.org/drawingml/2006/main" noChangeAspect="1"/>
           </p:cNvPicPr>
           <p:nvPr/>
         </p:nvPicPr>
         <p:blipFill>
-          <a:blip xmlns:r="http://schemas.openxmlformats.org/officeDocument/2006/relationships" xmlns:a="http://schemas.openxmlformats.org/drawingml/2006/main" r:embed="R1e694a4707334e38"/>
+          <a:blip xmlns:r="http://schemas.openxmlformats.org/officeDocument/2006/relationships" xmlns:a="http://schemas.openxmlformats.org/drawingml/2006/main" r:embed="Rb48cd50c69cf4652"/>
+          <a:srcRect xmlns:a="http://schemas.openxmlformats.org/drawingml/2006/main" l="50000" t="0" r="0" b="0"/>
           <a:stretch xmlns:a="http://schemas.openxmlformats.org/drawingml/2006/main"/>
         </p:blipFill>
         <p:spPr>
-          <a:xfrm xmlns:a="http://schemas.openxmlformats.org/drawingml/2006/main">
+          <a:xfrm xmlns:a="http://schemas.openxmlformats.org/drawingml/2006/main" flipH="0" flipV="0">
             <a:off x="5766681" y="1285875"/>
             <a:ext cx="5706889" cy="5048250"/>
           </a:xfrm>
@@ -5615,6 +5654,7 @@
           <a:lstStyle xmlns:a="http://schemas.openxmlformats.org/drawingml/2006/main"/>
           <a:p xmlns:a="http://schemas.openxmlformats.org/drawingml/2006/main">
             <a:pPr algn="l">
+              <a:buNone/>
               <a:defRPr sz="1200" b="1">
                 <a:solidFill>
                   <a:srgbClr val="59616B"/>
@@ -5671,6 +5711,7 @@
           <a:lstStyle xmlns:a="http://schemas.openxmlformats.org/drawingml/2006/main"/>
           <a:p xmlns:a="http://schemas.openxmlformats.org/drawingml/2006/main">
             <a:pPr algn="l">
+              <a:buNone/>
               <a:defRPr sz="3600" b="1">
                 <a:solidFill>
                   <a:srgbClr val="000000"/>
@@ -5727,6 +5768,7 @@
           <a:lstStyle xmlns:a="http://schemas.openxmlformats.org/drawingml/2006/main"/>
           <a:p xmlns:a="http://schemas.openxmlformats.org/drawingml/2006/main">
             <a:pPr algn="r">
+              <a:buNone/>
               <a:defRPr sz="1050" b="0">
                 <a:solidFill>
                   <a:srgbClr val="59616B"/>
@@ -5752,7 +5794,7 @@
       </p:sp>
       <p:graphicFrame>
         <p:nvGraphicFramePr>
-          <p:cNvPr id="21" name="Chart"/>
+          <p:cNvPr id="23" name="Chart"/>
           <p:cNvGraphicFramePr/>
           <p:nvPr/>
         </p:nvGraphicFramePr>
@@ -5762,7 +5804,7 @@
         </p:xfrm>
         <a:graphic xmlns:a="http://schemas.openxmlformats.org/drawingml/2006/main">
           <a:graphicData uri="http://schemas.openxmlformats.org/drawingml/2006/chart">
-            <c:chart xmlns:r="http://schemas.openxmlformats.org/officeDocument/2006/relationships" xmlns:c="http://schemas.openxmlformats.org/drawingml/2006/chart" r:id="R831ec2ee9ba24863"/>
+            <c:chart xmlns:r="http://schemas.openxmlformats.org/officeDocument/2006/relationships" xmlns:c="http://schemas.openxmlformats.org/drawingml/2006/chart" r:id="R39a551da7da6405f"/>
           </a:graphicData>
         </a:graphic>
       </p:graphicFrame>
@@ -5799,6 +5841,7 @@
           <a:lstStyle xmlns:a="http://schemas.openxmlformats.org/drawingml/2006/main"/>
           <a:p xmlns:a="http://schemas.openxmlformats.org/drawingml/2006/main">
             <a:pPr algn="l">
+              <a:buNone/>
               <a:defRPr sz="1500" b="1">
                 <a:solidFill>
                   <a:srgbClr val="000000"/>
@@ -5817,7 +5860,7 @@
                 <a:ea typeface="Arial"/>
                 <a:cs typeface="Arial"/>
               </a:rPr>
-              <a:t>0.94</a:t>
+              <a:t>0.93</a:t>
             </a:r>
           </a:p>
         </p:txBody>
@@ -5855,6 +5898,7 @@
           <a:lstStyle xmlns:a="http://schemas.openxmlformats.org/drawingml/2006/main"/>
           <a:p xmlns:a="http://schemas.openxmlformats.org/drawingml/2006/main">
             <a:pPr algn="l">
+              <a:buNone/>
               <a:defRPr sz="1500" b="1">
                 <a:solidFill>
                   <a:srgbClr val="000000"/>
@@ -5873,7 +5917,7 @@
                 <a:ea typeface="Arial"/>
                 <a:cs typeface="Arial"/>
               </a:rPr>
-              <a:t>0.93</a:t>
+              <a:t>0.92</a:t>
             </a:r>
           </a:p>
         </p:txBody>
@@ -5911,6 +5955,7 @@
           <a:lstStyle xmlns:a="http://schemas.openxmlformats.org/drawingml/2006/main"/>
           <a:p xmlns:a="http://schemas.openxmlformats.org/drawingml/2006/main">
             <a:pPr algn="l">
+              <a:buNone/>
               <a:defRPr sz="1500" b="1">
                 <a:solidFill>
                   <a:srgbClr val="000000"/>
@@ -5967,6 +6012,7 @@
           <a:lstStyle xmlns:a="http://schemas.openxmlformats.org/drawingml/2006/main"/>
           <a:p xmlns:a="http://schemas.openxmlformats.org/drawingml/2006/main">
             <a:pPr algn="l">
+              <a:buNone/>
               <a:defRPr sz="1500" b="1">
                 <a:solidFill>
                   <a:srgbClr val="000000"/>
@@ -5985,7 +6031,7 @@
                 <a:ea typeface="Arial"/>
                 <a:cs typeface="Arial"/>
               </a:rPr>
-              <a:t>0.81</a:t>
+              <a:t>0.82</a:t>
             </a:r>
           </a:p>
         </p:txBody>
@@ -6087,6 +6133,7 @@
           <a:lstStyle xmlns:a="http://schemas.openxmlformats.org/drawingml/2006/main"/>
           <a:p xmlns:a="http://schemas.openxmlformats.org/drawingml/2006/main">
             <a:pPr algn="l">
+              <a:buNone/>
               <a:defRPr sz="3900" b="1">
                 <a:solidFill>
                   <a:srgbClr val="000000"/>
@@ -6105,7 +6152,7 @@
                 <a:ea typeface="Arial"/>
                 <a:cs typeface="Arial"/>
               </a:rPr>
-              <a:t>0.0198</a:t>
+              <a:t>0.0303</a:t>
             </a:r>
           </a:p>
         </p:txBody>
@@ -6143,6 +6190,7 @@
           <a:lstStyle xmlns:a="http://schemas.openxmlformats.org/drawingml/2006/main"/>
           <a:p xmlns:a="http://schemas.openxmlformats.org/drawingml/2006/main">
             <a:pPr algn="l">
+              <a:buNone/>
               <a:defRPr sz="1650" b="0">
                 <a:solidFill>
                   <a:srgbClr val="59616B"/>
@@ -6263,6 +6311,7 @@
           <a:lstStyle xmlns:a="http://schemas.openxmlformats.org/drawingml/2006/main"/>
           <a:p xmlns:a="http://schemas.openxmlformats.org/drawingml/2006/main">
             <a:pPr algn="l">
+              <a:buNone/>
               <a:defRPr sz="3900" b="1">
                 <a:solidFill>
                   <a:srgbClr val="000000"/>
@@ -6281,7 +6330,7 @@
                 <a:ea typeface="Arial"/>
                 <a:cs typeface="Arial"/>
               </a:rPr>
-              <a:t>3.41 ms</a:t>
+              <a:t>3.33 ms</a:t>
             </a:r>
           </a:p>
         </p:txBody>
@@ -6319,6 +6368,7 @@
           <a:lstStyle xmlns:a="http://schemas.openxmlformats.org/drawingml/2006/main"/>
           <a:p xmlns:a="http://schemas.openxmlformats.org/drawingml/2006/main">
             <a:pPr algn="l">
+              <a:buNone/>
               <a:defRPr sz="1650" b="0">
                 <a:solidFill>
                   <a:srgbClr val="59616B"/>
@@ -6375,6 +6425,7 @@
           <a:lstStyle xmlns:a="http://schemas.openxmlformats.org/drawingml/2006/main"/>
           <a:p xmlns:a="http://schemas.openxmlformats.org/drawingml/2006/main">
             <a:pPr algn="r">
+              <a:buNone/>
               <a:defRPr sz="1575" b="1">
                 <a:solidFill>
                   <a:srgbClr val="000000"/>
@@ -6393,7 +6444,7 @@
                 <a:ea typeface="Arial"/>
                 <a:cs typeface="Arial"/>
               </a:rPr>
-              <a:t>3.42 MiB serialized  |  +/-100 ms shift costs at most 0.34 points</a:t>
+              <a:t>3.42 MiB serialized  |  +/-100 ms shift costs at most 0.38 points</a:t>
             </a:r>
           </a:p>
         </p:txBody>
@@ -6460,6 +6511,7 @@
           <a:lstStyle xmlns:a="http://schemas.openxmlformats.org/drawingml/2006/main"/>
           <a:p xmlns:a="http://schemas.openxmlformats.org/drawingml/2006/main">
             <a:pPr algn="l">
+              <a:buNone/>
               <a:defRPr sz="1200" b="1">
                 <a:solidFill>
                   <a:srgbClr val="59616B"/>
@@ -6516,6 +6568,7 @@
           <a:lstStyle xmlns:a="http://schemas.openxmlformats.org/drawingml/2006/main"/>
           <a:p xmlns:a="http://schemas.openxmlformats.org/drawingml/2006/main">
             <a:pPr algn="l">
+              <a:buNone/>
               <a:defRPr sz="3600" b="1">
                 <a:solidFill>
                   <a:srgbClr val="000000"/>
@@ -6572,6 +6625,7 @@
           <a:lstStyle xmlns:a="http://schemas.openxmlformats.org/drawingml/2006/main"/>
           <a:p xmlns:a="http://schemas.openxmlformats.org/drawingml/2006/main">
             <a:pPr algn="r">
+              <a:buNone/>
               <a:defRPr sz="1050" b="0">
                 <a:solidFill>
                   <a:srgbClr val="59616B"/>
@@ -6597,18 +6651,19 @@
       </p:sp>
       <p:pic>
         <p:nvPicPr>
-          <p:cNvPr id="16" name=""/>
+          <p:cNvPr id="18" name=""/>
           <p:cNvPicPr>
             <a:picLocks xmlns:a="http://schemas.openxmlformats.org/drawingml/2006/main" noChangeAspect="1"/>
           </p:cNvPicPr>
           <p:nvPr/>
         </p:nvPicPr>
         <p:blipFill>
-          <a:blip xmlns:r="http://schemas.openxmlformats.org/officeDocument/2006/relationships" xmlns:a="http://schemas.openxmlformats.org/drawingml/2006/main" r:embed="R133dcdf5d12045f5"/>
+          <a:blip xmlns:r="http://schemas.openxmlformats.org/officeDocument/2006/relationships" xmlns:a="http://schemas.openxmlformats.org/drawingml/2006/main" r:embed="Rbbfe69f2b67b4268"/>
+          <a:srcRect xmlns:a="http://schemas.openxmlformats.org/drawingml/2006/main" l="0" t="3500" r="50000" b="65000"/>
           <a:stretch xmlns:a="http://schemas.openxmlformats.org/drawingml/2006/main"/>
         </p:blipFill>
         <p:spPr>
-          <a:xfrm xmlns:a="http://schemas.openxmlformats.org/drawingml/2006/main">
+          <a:xfrm xmlns:a="http://schemas.openxmlformats.org/drawingml/2006/main" flipH="0" flipV="0">
             <a:off x="457200" y="1722973"/>
             <a:ext cx="7477125" cy="2935804"/>
           </a:xfrm>
@@ -6650,6 +6705,7 @@
           <a:lstStyle xmlns:a="http://schemas.openxmlformats.org/drawingml/2006/main"/>
           <a:p xmlns:a="http://schemas.openxmlformats.org/drawingml/2006/main">
             <a:pPr algn="ctr">
+              <a:buNone/>
               <a:defRPr sz="1875" b="1">
                 <a:solidFill>
                   <a:srgbClr val="000000"/>
@@ -6739,6 +6795,7 @@
           <a:lstStyle xmlns:a="http://schemas.openxmlformats.org/drawingml/2006/main"/>
           <a:p xmlns:a="http://schemas.openxmlformats.org/drawingml/2006/main">
             <a:pPr algn="l">
+              <a:buNone/>
               <a:defRPr sz="1650" b="1">
                 <a:solidFill>
                   <a:srgbClr val="59616B"/>
@@ -6795,6 +6852,7 @@
           <a:lstStyle xmlns:a="http://schemas.openxmlformats.org/drawingml/2006/main"/>
           <a:p xmlns:a="http://schemas.openxmlformats.org/drawingml/2006/main">
             <a:pPr algn="l">
+              <a:buNone/>
               <a:defRPr sz="2175" b="1">
                 <a:solidFill>
                   <a:srgbClr val="000000"/>
@@ -6813,7 +6871,7 @@
                 <a:ea typeface="Arial"/>
                 <a:cs typeface="Arial"/>
               </a:rPr>
-              <a:t>unknown  F1 = 0.854</a:t>
+              <a:t>unknown  F1 = 0.840</a:t>
             </a:r>
           </a:p>
         </p:txBody>
@@ -6851,6 +6909,7 @@
           <a:lstStyle xmlns:a="http://schemas.openxmlformats.org/drawingml/2006/main"/>
           <a:p xmlns:a="http://schemas.openxmlformats.org/drawingml/2006/main">
             <a:pPr algn="l">
+              <a:buNone/>
               <a:defRPr sz="1650" b="1">
                 <a:solidFill>
                   <a:srgbClr val="59616B"/>
@@ -6907,6 +6966,7 @@
           <a:lstStyle xmlns:a="http://schemas.openxmlformats.org/drawingml/2006/main"/>
           <a:p xmlns:a="http://schemas.openxmlformats.org/drawingml/2006/main">
             <a:pPr algn="l">
+              <a:buNone/>
               <a:defRPr sz="2100" b="1">
                 <a:solidFill>
                   <a:srgbClr val="000000"/>
@@ -6925,7 +6985,7 @@
                 <a:ea typeface="Arial"/>
                 <a:cs typeface="Arial"/>
               </a:rPr>
-              <a:t>down -&gt; no  (14 clips)</a:t>
+              <a:t>silence -&gt; up  (17 clips)</a:t>
             </a:r>
           </a:p>
         </p:txBody>
@@ -6963,6 +7023,7 @@
           <a:lstStyle xmlns:a="http://schemas.openxmlformats.org/drawingml/2006/main"/>
           <a:p xmlns:a="http://schemas.openxmlformats.org/drawingml/2006/main">
             <a:pPr algn="l">
+              <a:buNone/>
               <a:defRPr sz="1650" b="1">
                 <a:solidFill>
                   <a:srgbClr val="59616B"/>
@@ -7019,6 +7080,7 @@
           <a:lstStyle xmlns:a="http://schemas.openxmlformats.org/drawingml/2006/main"/>
           <a:p xmlns:a="http://schemas.openxmlformats.org/drawingml/2006/main">
             <a:pPr algn="l">
+              <a:buNone/>
               <a:defRPr sz="2025" b="1">
                 <a:solidFill>
                   <a:srgbClr val="C23B3B"/>
@@ -7104,6 +7166,7 @@
           <a:lstStyle xmlns:a="http://schemas.openxmlformats.org/drawingml/2006/main"/>
           <a:p xmlns:a="http://schemas.openxmlformats.org/drawingml/2006/main">
             <a:pPr algn="l">
+              <a:buNone/>
               <a:defRPr sz="1350" b="1">
                 <a:solidFill>
                   <a:srgbClr val="59616B"/>
@@ -7160,6 +7223,7 @@
           <a:lstStyle xmlns:a="http://schemas.openxmlformats.org/drawingml/2006/main"/>
           <a:p xmlns:a="http://schemas.openxmlformats.org/drawingml/2006/main">
             <a:pPr algn="l">
+              <a:buNone/>
               <a:defRPr sz="4050" b="1">
                 <a:solidFill>
                   <a:srgbClr val="000000"/>
@@ -7216,6 +7280,7 @@
           <a:lstStyle xmlns:a="http://schemas.openxmlformats.org/drawingml/2006/main"/>
           <a:p xmlns:a="http://schemas.openxmlformats.org/drawingml/2006/main">
             <a:pPr algn="l">
+              <a:buNone/>
               <a:defRPr sz="1800" b="1">
                 <a:solidFill>
                   <a:srgbClr val="3D8DFF"/>
@@ -7272,6 +7337,7 @@
           <a:lstStyle xmlns:a="http://schemas.openxmlformats.org/drawingml/2006/main"/>
           <a:p xmlns:a="http://schemas.openxmlformats.org/drawingml/2006/main">
             <a:pPr algn="l">
+              <a:buNone/>
               <a:defRPr sz="2100" b="1">
                 <a:solidFill>
                   <a:srgbClr val="000000"/>
@@ -7328,6 +7394,7 @@
           <a:lstStyle xmlns:a="http://schemas.openxmlformats.org/drawingml/2006/main"/>
           <a:p xmlns:a="http://schemas.openxmlformats.org/drawingml/2006/main">
             <a:pPr algn="l">
+              <a:buNone/>
               <a:defRPr sz="1725" b="0">
                 <a:solidFill>
                   <a:srgbClr val="59616B"/>
@@ -7346,7 +7413,7 @@
                 <a:ea typeface="Arial"/>
                 <a:cs typeface="Arial"/>
               </a:rPr>
-              <a:t>Log-Mel convolution plus temporal recurrence reached 0.9421 test macro-F1.</a:t>
+              <a:t>Log-Mel convolution plus temporal recurrence reached 0.9315 test macro-F1.</a:t>
             </a:r>
           </a:p>
         </p:txBody>
@@ -7415,6 +7482,7 @@
           <a:lstStyle xmlns:a="http://schemas.openxmlformats.org/drawingml/2006/main"/>
           <a:p xmlns:a="http://schemas.openxmlformats.org/drawingml/2006/main">
             <a:pPr algn="l">
+              <a:buNone/>
               <a:defRPr sz="1800" b="1">
                 <a:solidFill>
                   <a:srgbClr val="3D8DFF"/>
@@ -7471,6 +7539,7 @@
           <a:lstStyle xmlns:a="http://schemas.openxmlformats.org/drawingml/2006/main"/>
           <a:p xmlns:a="http://schemas.openxmlformats.org/drawingml/2006/main">
             <a:pPr algn="l">
+              <a:buNone/>
               <a:defRPr sz="2100" b="1">
                 <a:solidFill>
                   <a:srgbClr val="000000"/>
@@ -7527,6 +7596,7 @@
           <a:lstStyle xmlns:a="http://schemas.openxmlformats.org/drawingml/2006/main"/>
           <a:p xmlns:a="http://schemas.openxmlformats.org/drawingml/2006/main">
             <a:pPr algn="l">
+              <a:buNone/>
               <a:defRPr sz="1725" b="0">
                 <a:solidFill>
                   <a:srgbClr val="59616B"/>
@@ -7614,6 +7684,7 @@
           <a:lstStyle xmlns:a="http://schemas.openxmlformats.org/drawingml/2006/main"/>
           <a:p xmlns:a="http://schemas.openxmlformats.org/drawingml/2006/main">
             <a:pPr algn="l">
+              <a:buNone/>
               <a:defRPr sz="1800" b="1">
                 <a:solidFill>
                   <a:srgbClr val="3D8DFF"/>
@@ -7670,6 +7741,7 @@
           <a:lstStyle xmlns:a="http://schemas.openxmlformats.org/drawingml/2006/main"/>
           <a:p xmlns:a="http://schemas.openxmlformats.org/drawingml/2006/main">
             <a:pPr algn="l">
+              <a:buNone/>
               <a:defRPr sz="2100" b="1">
                 <a:solidFill>
                   <a:srgbClr val="000000"/>
@@ -7726,6 +7798,7 @@
           <a:lstStyle xmlns:a="http://schemas.openxmlformats.org/drawingml/2006/main"/>
           <a:p xmlns:a="http://schemas.openxmlformats.org/drawingml/2006/main">
             <a:pPr algn="l">
+              <a:buNone/>
               <a:defRPr sz="1725" b="0">
                 <a:solidFill>
                   <a:srgbClr val="59616B"/>
@@ -7815,6 +7888,7 @@
           <a:lstStyle xmlns:a="http://schemas.openxmlformats.org/drawingml/2006/main"/>
           <a:p xmlns:a="http://schemas.openxmlformats.org/drawingml/2006/main">
             <a:pPr algn="ctr">
+              <a:buNone/>
               <a:defRPr sz="1650" b="1">
                 <a:solidFill>
                   <a:srgbClr val="000000"/>
@@ -7871,6 +7945,7 @@
           <a:lstStyle xmlns:a="http://schemas.openxmlformats.org/drawingml/2006/main"/>
           <a:p xmlns:a="http://schemas.openxmlformats.org/drawingml/2006/main">
             <a:pPr algn="r">
+              <a:buNone/>
               <a:defRPr sz="1050" b="0">
                 <a:solidFill>
                   <a:srgbClr val="59616B"/>
@@ -7956,6 +8031,7 @@
           <a:lstStyle xmlns:a="http://schemas.openxmlformats.org/drawingml/2006/main"/>
           <a:p xmlns:a="http://schemas.openxmlformats.org/drawingml/2006/main">
             <a:pPr algn="l">
+              <a:buNone/>
               <a:defRPr sz="1200" b="1">
                 <a:solidFill>
                   <a:srgbClr val="59616B"/>
@@ -8012,6 +8088,7 @@
           <a:lstStyle xmlns:a="http://schemas.openxmlformats.org/drawingml/2006/main"/>
           <a:p xmlns:a="http://schemas.openxmlformats.org/drawingml/2006/main">
             <a:pPr algn="l">
+              <a:buNone/>
               <a:defRPr sz="3600" b="1">
                 <a:solidFill>
                   <a:srgbClr val="000000"/>
@@ -8068,6 +8145,7 @@
           <a:lstStyle xmlns:a="http://schemas.openxmlformats.org/drawingml/2006/main"/>
           <a:p xmlns:a="http://schemas.openxmlformats.org/drawingml/2006/main">
             <a:pPr algn="r">
+              <a:buNone/>
               <a:defRPr sz="1050" b="0">
                 <a:solidFill>
                   <a:srgbClr val="59616B"/>
@@ -8124,6 +8202,7 @@
           <a:lstStyle xmlns:a="http://schemas.openxmlformats.org/drawingml/2006/main"/>
           <a:p xmlns:a="http://schemas.openxmlformats.org/drawingml/2006/main">
             <a:pPr algn="l">
+              <a:buNone/>
               <a:defRPr sz="1650" b="1">
                 <a:solidFill>
                   <a:srgbClr val="59616B"/>
@@ -8180,6 +8259,7 @@
           <a:lstStyle xmlns:a="http://schemas.openxmlformats.org/drawingml/2006/main"/>
           <a:p xmlns:a="http://schemas.openxmlformats.org/drawingml/2006/main">
             <a:pPr algn="l">
+              <a:buNone/>
               <a:defRPr sz="2400" b="1">
                 <a:solidFill>
                   <a:srgbClr val="000000"/>
@@ -8236,6 +8316,7 @@
           <a:lstStyle xmlns:a="http://schemas.openxmlformats.org/drawingml/2006/main"/>
           <a:p xmlns:a="http://schemas.openxmlformats.org/drawingml/2006/main">
             <a:pPr algn="l">
+              <a:buNone/>
               <a:defRPr sz="1650" b="1">
                 <a:solidFill>
                   <a:srgbClr val="59616B"/>
@@ -8292,6 +8373,7 @@
           <a:lstStyle xmlns:a="http://schemas.openxmlformats.org/drawingml/2006/main"/>
           <a:p xmlns:a="http://schemas.openxmlformats.org/drawingml/2006/main">
             <a:pPr algn="l">
+              <a:buNone/>
               <a:defRPr sz="2400" b="1">
                 <a:solidFill>
                   <a:srgbClr val="000000"/>
@@ -8412,6 +8494,7 @@
           <a:lstStyle xmlns:a="http://schemas.openxmlformats.org/drawingml/2006/main"/>
           <a:p xmlns:a="http://schemas.openxmlformats.org/drawingml/2006/main">
             <a:pPr algn="l">
+              <a:buNone/>
               <a:defRPr sz="3900" b="1">
                 <a:solidFill>
                   <a:srgbClr val="000000"/>
@@ -8468,6 +8551,7 @@
           <a:lstStyle xmlns:a="http://schemas.openxmlformats.org/drawingml/2006/main"/>
           <a:p xmlns:a="http://schemas.openxmlformats.org/drawingml/2006/main">
             <a:pPr algn="l">
+              <a:buNone/>
               <a:defRPr sz="1650" b="0">
                 <a:solidFill>
                   <a:srgbClr val="59616B"/>
@@ -8588,6 +8672,7 @@
           <a:lstStyle xmlns:a="http://schemas.openxmlformats.org/drawingml/2006/main"/>
           <a:p xmlns:a="http://schemas.openxmlformats.org/drawingml/2006/main">
             <a:pPr algn="l">
+              <a:buNone/>
               <a:defRPr sz="3900" b="1">
                 <a:solidFill>
                   <a:srgbClr val="000000"/>
@@ -8644,6 +8729,7 @@
           <a:lstStyle xmlns:a="http://schemas.openxmlformats.org/drawingml/2006/main"/>
           <a:p xmlns:a="http://schemas.openxmlformats.org/drawingml/2006/main">
             <a:pPr algn="l">
+              <a:buNone/>
               <a:defRPr sz="1650" b="0">
                 <a:solidFill>
                   <a:srgbClr val="59616B"/>
@@ -8662,7 +8748,7 @@
                 <a:ea typeface="Arial"/>
                 <a:cs typeface="Arial"/>
               </a:rPr>
-              <a:t>balanced modeled classes</a:t>
+              <a:t>modeled classes</a:t>
             </a:r>
           </a:p>
         </p:txBody>
@@ -8764,6 +8850,7 @@
           <a:lstStyle xmlns:a="http://schemas.openxmlformats.org/drawingml/2006/main"/>
           <a:p xmlns:a="http://schemas.openxmlformats.org/drawingml/2006/main">
             <a:pPr algn="l">
+              <a:buNone/>
               <a:defRPr sz="3900" b="1">
                 <a:solidFill>
                   <a:srgbClr val="000000"/>
@@ -8820,6 +8907,7 @@
           <a:lstStyle xmlns:a="http://schemas.openxmlformats.org/drawingml/2006/main"/>
           <a:p xmlns:a="http://schemas.openxmlformats.org/drawingml/2006/main">
             <a:pPr algn="l">
+              <a:buNone/>
               <a:defRPr sz="1650" b="0">
                 <a:solidFill>
                   <a:srgbClr val="59616B"/>
@@ -8876,6 +8964,7 @@
           <a:lstStyle xmlns:a="http://schemas.openxmlformats.org/drawingml/2006/main"/>
           <a:p xmlns:a="http://schemas.openxmlformats.org/drawingml/2006/main">
             <a:pPr algn="l">
+              <a:buNone/>
               <a:defRPr sz="1800" b="0">
                 <a:solidFill>
                   <a:srgbClr val="59616B"/>
@@ -8961,6 +9050,7 @@
           <a:lstStyle xmlns:a="http://schemas.openxmlformats.org/drawingml/2006/main"/>
           <a:p xmlns:a="http://schemas.openxmlformats.org/drawingml/2006/main">
             <a:pPr algn="l">
+              <a:buNone/>
               <a:defRPr sz="1200" b="1">
                 <a:solidFill>
                   <a:srgbClr val="59616B"/>
@@ -9017,6 +9107,7 @@
           <a:lstStyle xmlns:a="http://schemas.openxmlformats.org/drawingml/2006/main"/>
           <a:p xmlns:a="http://schemas.openxmlformats.org/drawingml/2006/main">
             <a:pPr algn="l">
+              <a:buNone/>
               <a:defRPr sz="3600" b="1">
                 <a:solidFill>
                   <a:srgbClr val="000000"/>
@@ -9035,7 +9126,7 @@
                 <a:ea typeface="Arial"/>
                 <a:cs typeface="Arial"/>
               </a:rPr>
-              <a:t>Balanced modeling preserves the raw audit</a:t>
+              <a:t>Near-balanced modeling preserves the raw audit</a:t>
             </a:r>
           </a:p>
         </p:txBody>
@@ -9073,6 +9164,7 @@
           <a:lstStyle xmlns:a="http://schemas.openxmlformats.org/drawingml/2006/main"/>
           <a:p xmlns:a="http://schemas.openxmlformats.org/drawingml/2006/main">
             <a:pPr algn="r">
+              <a:buNone/>
               <a:defRPr sz="1050" b="0">
                 <a:solidFill>
                   <a:srgbClr val="59616B"/>
@@ -9193,6 +9285,7 @@
           <a:lstStyle xmlns:a="http://schemas.openxmlformats.org/drawingml/2006/main"/>
           <a:p xmlns:a="http://schemas.openxmlformats.org/drawingml/2006/main">
             <a:pPr algn="l">
+              <a:buNone/>
               <a:defRPr sz="3900" b="1">
                 <a:solidFill>
                   <a:srgbClr val="000000"/>
@@ -9249,6 +9342,7 @@
           <a:lstStyle xmlns:a="http://schemas.openxmlformats.org/drawingml/2006/main"/>
           <a:p xmlns:a="http://schemas.openxmlformats.org/drawingml/2006/main">
             <a:pPr algn="l">
+              <a:buNone/>
               <a:defRPr sz="1650" b="0">
                 <a:solidFill>
                   <a:srgbClr val="59616B"/>
@@ -9369,6 +9463,7 @@
           <a:lstStyle xmlns:a="http://schemas.openxmlformats.org/drawingml/2006/main"/>
           <a:p xmlns:a="http://schemas.openxmlformats.org/drawingml/2006/main">
             <a:pPr algn="l">
+              <a:buNone/>
               <a:defRPr sz="3900" b="1">
                 <a:solidFill>
                   <a:srgbClr val="000000"/>
@@ -9425,6 +9520,7 @@
           <a:lstStyle xmlns:a="http://schemas.openxmlformats.org/drawingml/2006/main"/>
           <a:p xmlns:a="http://schemas.openxmlformats.org/drawingml/2006/main">
             <a:pPr algn="l">
+              <a:buNone/>
               <a:defRPr sz="1650" b="0">
                 <a:solidFill>
                   <a:srgbClr val="59616B"/>
@@ -9481,6 +9577,7 @@
           <a:lstStyle xmlns:a="http://schemas.openxmlformats.org/drawingml/2006/main"/>
           <a:p xmlns:a="http://schemas.openxmlformats.org/drawingml/2006/main">
             <a:pPr algn="l">
+              <a:buNone/>
               <a:defRPr sz="2400" b="1">
                 <a:solidFill>
                   <a:srgbClr val="000000"/>
@@ -9537,6 +9634,7 @@
           <a:lstStyle xmlns:a="http://schemas.openxmlformats.org/drawingml/2006/main"/>
           <a:p xmlns:a="http://schemas.openxmlformats.org/drawingml/2006/main">
             <a:pPr algn="l">
+              <a:buNone/>
               <a:defRPr sz="1650" b="0">
                 <a:solidFill>
                   <a:srgbClr val="59616B"/>
@@ -9555,21 +9653,21 @@
                 <a:ea typeface="Arial"/>
                 <a:cs typeface="Arial"/>
               </a:rPr>
-              <a:t>Each class contains the same deterministic unknown and silence proportions across the official splits.</a:t>
+              <a:t>All target recordings are retained; unknown and silence are constructed at controlled ratios within each official split.</a:t>
             </a:r>
           </a:p>
         </p:txBody>
       </p:sp>
       <p:pic>
         <p:nvPicPr>
-          <p:cNvPr id="28" name=""/>
+          <p:cNvPr id="30" name=""/>
           <p:cNvPicPr>
             <a:picLocks xmlns:a="http://schemas.openxmlformats.org/drawingml/2006/main" noChangeAspect="1"/>
           </p:cNvPicPr>
           <p:nvPr/>
         </p:nvPicPr>
         <p:blipFill>
-          <a:blip xmlns:r="http://schemas.openxmlformats.org/officeDocument/2006/relationships" xmlns:a="http://schemas.openxmlformats.org/drawingml/2006/main" r:embed="Rc2fea50c046946b4"/>
+          <a:blip xmlns:r="http://schemas.openxmlformats.org/officeDocument/2006/relationships" xmlns:a="http://schemas.openxmlformats.org/drawingml/2006/main" r:embed="Reddbd40fee954ae3"/>
           <a:stretch xmlns:a="http://schemas.openxmlformats.org/drawingml/2006/main"/>
         </p:blipFill>
         <p:spPr>
@@ -9644,6 +9742,7 @@
           <a:lstStyle xmlns:a="http://schemas.openxmlformats.org/drawingml/2006/main"/>
           <a:p xmlns:a="http://schemas.openxmlformats.org/drawingml/2006/main">
             <a:pPr algn="l">
+              <a:buNone/>
               <a:defRPr sz="1200" b="1">
                 <a:solidFill>
                   <a:srgbClr val="59616B"/>
@@ -9700,6 +9799,7 @@
           <a:lstStyle xmlns:a="http://schemas.openxmlformats.org/drawingml/2006/main"/>
           <a:p xmlns:a="http://schemas.openxmlformats.org/drawingml/2006/main">
             <a:pPr algn="l">
+              <a:buNone/>
               <a:defRPr sz="3600" b="1">
                 <a:solidFill>
                   <a:srgbClr val="000000"/>
@@ -9756,6 +9856,7 @@
           <a:lstStyle xmlns:a="http://schemas.openxmlformats.org/drawingml/2006/main"/>
           <a:p xmlns:a="http://schemas.openxmlformats.org/drawingml/2006/main">
             <a:pPr algn="r">
+              <a:buNone/>
               <a:defRPr sz="1050" b="0">
                 <a:solidFill>
                   <a:srgbClr val="59616B"/>
@@ -9781,14 +9882,14 @@
       </p:sp>
       <p:pic>
         <p:nvPicPr>
-          <p:cNvPr id="10" name=""/>
+          <p:cNvPr id="12" name=""/>
           <p:cNvPicPr>
             <a:picLocks xmlns:a="http://schemas.openxmlformats.org/drawingml/2006/main" noChangeAspect="1"/>
           </p:cNvPicPr>
           <p:nvPr/>
         </p:nvPicPr>
         <p:blipFill>
-          <a:blip xmlns:r="http://schemas.openxmlformats.org/officeDocument/2006/relationships" xmlns:a="http://schemas.openxmlformats.org/drawingml/2006/main" r:embed="R93f0dc9b68be43d2"/>
+          <a:blip xmlns:r="http://schemas.openxmlformats.org/officeDocument/2006/relationships" xmlns:a="http://schemas.openxmlformats.org/drawingml/2006/main" r:embed="R7b55816f4cf4493a"/>
           <a:stretch xmlns:a="http://schemas.openxmlformats.org/drawingml/2006/main"/>
         </p:blipFill>
         <p:spPr>
@@ -9834,6 +9935,7 @@
           <a:lstStyle xmlns:a="http://schemas.openxmlformats.org/drawingml/2006/main"/>
           <a:p xmlns:a="http://schemas.openxmlformats.org/drawingml/2006/main">
             <a:pPr algn="l">
+              <a:buNone/>
               <a:defRPr sz="1650" b="1">
                 <a:solidFill>
                   <a:srgbClr val="3D8DFF"/>
@@ -9890,6 +9992,7 @@
           <a:lstStyle xmlns:a="http://schemas.openxmlformats.org/drawingml/2006/main"/>
           <a:p xmlns:a="http://schemas.openxmlformats.org/drawingml/2006/main">
             <a:pPr algn="l">
+              <a:buNone/>
               <a:defRPr sz="1650" b="0">
                 <a:solidFill>
                   <a:srgbClr val="000000"/>
@@ -9975,6 +10078,7 @@
           <a:lstStyle xmlns:a="http://schemas.openxmlformats.org/drawingml/2006/main"/>
           <a:p xmlns:a="http://schemas.openxmlformats.org/drawingml/2006/main">
             <a:pPr algn="l">
+              <a:buNone/>
               <a:defRPr sz="1200" b="1">
                 <a:solidFill>
                   <a:srgbClr val="59616B"/>
@@ -10031,6 +10135,7 @@
           <a:lstStyle xmlns:a="http://schemas.openxmlformats.org/drawingml/2006/main"/>
           <a:p xmlns:a="http://schemas.openxmlformats.org/drawingml/2006/main">
             <a:pPr algn="l">
+              <a:buNone/>
               <a:defRPr sz="3600" b="1">
                 <a:solidFill>
                   <a:srgbClr val="000000"/>
@@ -10087,6 +10192,7 @@
           <a:lstStyle xmlns:a="http://schemas.openxmlformats.org/drawingml/2006/main"/>
           <a:p xmlns:a="http://schemas.openxmlformats.org/drawingml/2006/main">
             <a:pPr algn="r">
+              <a:buNone/>
               <a:defRPr sz="1050" b="0">
                 <a:solidFill>
                   <a:srgbClr val="59616B"/>
@@ -10143,6 +10249,7 @@
           <a:lstStyle xmlns:a="http://schemas.openxmlformats.org/drawingml/2006/main"/>
           <a:p xmlns:a="http://schemas.openxmlformats.org/drawingml/2006/main">
             <a:pPr algn="l">
+              <a:buNone/>
               <a:defRPr sz="1800" b="0">
                 <a:solidFill>
                   <a:srgbClr val="59616B"/>
@@ -10161,7 +10268,7 @@
                 <a:ea typeface="Arial"/>
                 <a:cs typeface="Arial"/>
               </a:rPr>
-              <a:t>Official lists define validation and test; all remaining speakers form training. Silence windows are also non-overlapping across splits.</a:t>
+              <a:t>Official lists define validation and test; all remaining speakers train. Background audio is reserved 80% / 10% / 10% by split.</a:t>
             </a:r>
           </a:p>
         </p:txBody>
@@ -10263,6 +10370,7 @@
           <a:lstStyle xmlns:a="http://schemas.openxmlformats.org/drawingml/2006/main"/>
           <a:p xmlns:a="http://schemas.openxmlformats.org/drawingml/2006/main">
             <a:pPr algn="l">
+              <a:buNone/>
               <a:defRPr sz="3900" b="1">
                 <a:solidFill>
                   <a:srgbClr val="000000"/>
@@ -10319,6 +10427,7 @@
           <a:lstStyle xmlns:a="http://schemas.openxmlformats.org/drawingml/2006/main"/>
           <a:p xmlns:a="http://schemas.openxmlformats.org/drawingml/2006/main">
             <a:pPr algn="l">
+              <a:buNone/>
               <a:defRPr sz="1650" b="0">
                 <a:solidFill>
                   <a:srgbClr val="59616B"/>
@@ -10439,6 +10548,7 @@
           <a:lstStyle xmlns:a="http://schemas.openxmlformats.org/drawingml/2006/main"/>
           <a:p xmlns:a="http://schemas.openxmlformats.org/drawingml/2006/main">
             <a:pPr algn="l">
+              <a:buNone/>
               <a:defRPr sz="3900" b="1">
                 <a:solidFill>
                   <a:srgbClr val="000000"/>
@@ -10495,6 +10605,7 @@
           <a:lstStyle xmlns:a="http://schemas.openxmlformats.org/drawingml/2006/main"/>
           <a:p xmlns:a="http://schemas.openxmlformats.org/drawingml/2006/main">
             <a:pPr algn="l">
+              <a:buNone/>
               <a:defRPr sz="1650" b="0">
                 <a:solidFill>
                   <a:srgbClr val="59616B"/>
@@ -10615,6 +10726,7 @@
           <a:lstStyle xmlns:a="http://schemas.openxmlformats.org/drawingml/2006/main"/>
           <a:p xmlns:a="http://schemas.openxmlformats.org/drawingml/2006/main">
             <a:pPr algn="l">
+              <a:buNone/>
               <a:defRPr sz="3900" b="1">
                 <a:solidFill>
                   <a:srgbClr val="000000"/>
@@ -10671,6 +10783,7 @@
           <a:lstStyle xmlns:a="http://schemas.openxmlformats.org/drawingml/2006/main"/>
           <a:p xmlns:a="http://schemas.openxmlformats.org/drawingml/2006/main">
             <a:pPr algn="l">
+              <a:buNone/>
               <a:defRPr sz="1650" b="0">
                 <a:solidFill>
                   <a:srgbClr val="59616B"/>
@@ -10727,6 +10840,7 @@
           <a:lstStyle xmlns:a="http://schemas.openxmlformats.org/drawingml/2006/main"/>
           <a:p xmlns:a="http://schemas.openxmlformats.org/drawingml/2006/main">
             <a:pPr algn="l">
+              <a:buNone/>
               <a:defRPr sz="1950" b="1">
                 <a:solidFill>
                   <a:srgbClr val="000000"/>
@@ -10783,6 +10897,7 @@
           <a:lstStyle xmlns:a="http://schemas.openxmlformats.org/drawingml/2006/main"/>
           <a:p xmlns:a="http://schemas.openxmlformats.org/drawingml/2006/main">
             <a:pPr algn="l">
+              <a:buNone/>
               <a:defRPr sz="1725" b="0">
                 <a:solidFill>
                   <a:srgbClr val="000000"/>
@@ -10801,11 +10916,12 @@
                 <a:ea typeface="Arial"/>
                 <a:cs typeface="Arial"/>
               </a:rPr>
-              <a:t>- speaker-disjoint validation</a:t>
+              <a:t>- speaker-disjoint splits + silence regions</a:t>
             </a:r>
           </a:p>
           <a:p xmlns:a="http://schemas.openxmlformats.org/drawingml/2006/main">
             <a:pPr algn="l">
+              <a:buNone/>
               <a:defRPr sz="1725" b="0">
                 <a:solidFill>
                   <a:srgbClr val="000000"/>
@@ -10824,30 +10940,7 @@
                 <a:ea typeface="Arial"/>
                 <a:cs typeface="Arial"/>
               </a:rPr>
-              <a:t>- cross-split silence-region checks</a:t>
-            </a:r>
-          </a:p>
-          <a:p xmlns:a="http://schemas.openxmlformats.org/drawingml/2006/main">
-            <a:pPr algn="l">
-              <a:defRPr sz="1725" b="0">
-                <a:solidFill>
-                  <a:srgbClr val="000000"/>
-                </a:solidFill>
-                <a:latin typeface="Arial"/>
-                <a:ea typeface="Arial"/>
-                <a:cs typeface="Arial"/>
-              </a:defRPr>
-            </a:pPr>
-            <a:r>
-              <a:rPr sz="1725" b="0">
-                <a:solidFill>
-                  <a:srgbClr val="000000"/>
-                </a:solidFill>
-                <a:latin typeface="Arial"/>
-                <a:ea typeface="Arial"/>
-                <a:cs typeface="Arial"/>
-              </a:rPr>
-              <a:t>- train-only normalization statistics</a:t>
+              <a:t>- split-aware noise + train-only statistics</a:t>
             </a:r>
           </a:p>
         </p:txBody>
@@ -10885,6 +10978,7 @@
           <a:lstStyle xmlns:a="http://schemas.openxmlformats.org/drawingml/2006/main"/>
           <a:p xmlns:a="http://schemas.openxmlformats.org/drawingml/2006/main">
             <a:pPr algn="r">
+              <a:buNone/>
               <a:defRPr sz="1800" b="1">
                 <a:solidFill>
                   <a:srgbClr val="C23B3B"/>
@@ -10941,6 +11035,7 @@
           <a:lstStyle xmlns:a="http://schemas.openxmlformats.org/drawingml/2006/main"/>
           <a:p xmlns:a="http://schemas.openxmlformats.org/drawingml/2006/main">
             <a:pPr algn="r">
+              <a:buNone/>
               <a:defRPr sz="1500" b="0">
                 <a:solidFill>
                   <a:srgbClr val="59616B"/>
@@ -11026,6 +11121,7 @@
           <a:lstStyle xmlns:a="http://schemas.openxmlformats.org/drawingml/2006/main"/>
           <a:p xmlns:a="http://schemas.openxmlformats.org/drawingml/2006/main">
             <a:pPr algn="l">
+              <a:buNone/>
               <a:defRPr sz="1200" b="1">
                 <a:solidFill>
                   <a:srgbClr val="59616B"/>
@@ -11082,6 +11178,7 @@
           <a:lstStyle xmlns:a="http://schemas.openxmlformats.org/drawingml/2006/main"/>
           <a:p xmlns:a="http://schemas.openxmlformats.org/drawingml/2006/main">
             <a:pPr algn="l">
+              <a:buNone/>
               <a:defRPr sz="3600" b="1">
                 <a:solidFill>
                   <a:srgbClr val="000000"/>
@@ -11138,6 +11235,7 @@
           <a:lstStyle xmlns:a="http://schemas.openxmlformats.org/drawingml/2006/main"/>
           <a:p xmlns:a="http://schemas.openxmlformats.org/drawingml/2006/main">
             <a:pPr algn="r">
+              <a:buNone/>
               <a:defRPr sz="1050" b="0">
                 <a:solidFill>
                   <a:srgbClr val="59616B"/>
@@ -11295,7 +11393,7 @@
       </p:sp>
       <p:cxnSp>
         <p:nvCxnSpPr>
-          <p:cNvPr id="27" name=""/>
+          <p:cNvPr id="47" name=""/>
           <p:cNvCxnSpPr>
             <a:stCxn xmlns:a="http://schemas.openxmlformats.org/drawingml/2006/main" id="5" idx="1"/>
             <a:endCxn xmlns:a="http://schemas.openxmlformats.org/drawingml/2006/main" id="4" idx="3"/>
@@ -11321,7 +11419,7 @@
       </p:cxnSp>
       <p:cxnSp>
         <p:nvCxnSpPr>
-          <p:cNvPr id="28" name=""/>
+          <p:cNvPr id="48" name=""/>
           <p:cNvCxnSpPr>
             <a:stCxn xmlns:a="http://schemas.openxmlformats.org/drawingml/2006/main" id="6" idx="1"/>
             <a:endCxn xmlns:a="http://schemas.openxmlformats.org/drawingml/2006/main" id="5" idx="3"/>
@@ -11347,7 +11445,7 @@
       </p:cxnSp>
       <p:cxnSp>
         <p:nvCxnSpPr>
-          <p:cNvPr id="29" name=""/>
+          <p:cNvPr id="49" name=""/>
           <p:cNvCxnSpPr>
             <a:stCxn xmlns:a="http://schemas.openxmlformats.org/drawingml/2006/main" id="7" idx="1"/>
             <a:endCxn xmlns:a="http://schemas.openxmlformats.org/drawingml/2006/main" id="6" idx="3"/>
@@ -11404,6 +11502,7 @@
           <a:lstStyle xmlns:a="http://schemas.openxmlformats.org/drawingml/2006/main"/>
           <a:p xmlns:a="http://schemas.openxmlformats.org/drawingml/2006/main">
             <a:pPr algn="l">
+              <a:buNone/>
               <a:defRPr sz="2175" b="1">
                 <a:solidFill>
                   <a:srgbClr val="000000"/>
@@ -11460,6 +11559,7 @@
           <a:lstStyle xmlns:a="http://schemas.openxmlformats.org/drawingml/2006/main"/>
           <a:p xmlns:a="http://schemas.openxmlformats.org/drawingml/2006/main">
             <a:pPr algn="l">
+              <a:buNone/>
               <a:defRPr sz="1650" b="0">
                 <a:solidFill>
                   <a:srgbClr val="59616B"/>
@@ -11483,6 +11583,7 @@
           </a:p>
           <a:p xmlns:a="http://schemas.openxmlformats.org/drawingml/2006/main">
             <a:pPr algn="l">
+              <a:buNone/>
               <a:defRPr sz="1650" b="0">
                 <a:solidFill>
                   <a:srgbClr val="59616B"/>
@@ -11539,6 +11640,7 @@
           <a:lstStyle xmlns:a="http://schemas.openxmlformats.org/drawingml/2006/main"/>
           <a:p xmlns:a="http://schemas.openxmlformats.org/drawingml/2006/main">
             <a:pPr algn="l">
+              <a:buNone/>
               <a:defRPr sz="2175" b="1">
                 <a:solidFill>
                   <a:srgbClr val="000000"/>
@@ -11595,6 +11697,7 @@
           <a:lstStyle xmlns:a="http://schemas.openxmlformats.org/drawingml/2006/main"/>
           <a:p xmlns:a="http://schemas.openxmlformats.org/drawingml/2006/main">
             <a:pPr algn="l">
+              <a:buNone/>
               <a:defRPr sz="1650" b="0">
                 <a:solidFill>
                   <a:srgbClr val="59616B"/>
@@ -11618,6 +11721,7 @@
           </a:p>
           <a:p xmlns:a="http://schemas.openxmlformats.org/drawingml/2006/main">
             <a:pPr algn="l">
+              <a:buNone/>
               <a:defRPr sz="1650" b="0">
                 <a:solidFill>
                   <a:srgbClr val="59616B"/>
@@ -11674,6 +11778,7 @@
           <a:lstStyle xmlns:a="http://schemas.openxmlformats.org/drawingml/2006/main"/>
           <a:p xmlns:a="http://schemas.openxmlformats.org/drawingml/2006/main">
             <a:pPr algn="l">
+              <a:buNone/>
               <a:defRPr sz="2175" b="1">
                 <a:solidFill>
                   <a:srgbClr val="000000"/>
@@ -11730,6 +11835,7 @@
           <a:lstStyle xmlns:a="http://schemas.openxmlformats.org/drawingml/2006/main"/>
           <a:p xmlns:a="http://schemas.openxmlformats.org/drawingml/2006/main">
             <a:pPr algn="l">
+              <a:buNone/>
               <a:defRPr sz="1650" b="0">
                 <a:solidFill>
                   <a:srgbClr val="59616B"/>
@@ -11753,6 +11859,7 @@
           </a:p>
           <a:p xmlns:a="http://schemas.openxmlformats.org/drawingml/2006/main">
             <a:pPr algn="l">
+              <a:buNone/>
               <a:defRPr sz="1650" b="0">
                 <a:solidFill>
                   <a:srgbClr val="59616B"/>
@@ -11809,6 +11916,7 @@
           <a:lstStyle xmlns:a="http://schemas.openxmlformats.org/drawingml/2006/main"/>
           <a:p xmlns:a="http://schemas.openxmlformats.org/drawingml/2006/main">
             <a:pPr algn="l">
+              <a:buNone/>
               <a:defRPr sz="2175" b="1">
                 <a:solidFill>
                   <a:srgbClr val="000000"/>
@@ -11865,6 +11973,7 @@
           <a:lstStyle xmlns:a="http://schemas.openxmlformats.org/drawingml/2006/main"/>
           <a:p xmlns:a="http://schemas.openxmlformats.org/drawingml/2006/main">
             <a:pPr algn="l">
+              <a:buNone/>
               <a:defRPr sz="1650" b="0">
                 <a:solidFill>
                   <a:srgbClr val="59616B"/>
@@ -11883,11 +11992,12 @@
                 <a:ea typeface="Arial"/>
                 <a:cs typeface="Arial"/>
               </a:rPr>
-              <a:t>40 x 101 map</a:t>
+              <a:t>40 x 98 map</a:t>
             </a:r>
           </a:p>
           <a:p xmlns:a="http://schemas.openxmlformats.org/drawingml/2006/main">
             <a:pPr algn="l">
+              <a:buNone/>
               <a:defRPr sz="1650" b="0">
                 <a:solidFill>
                   <a:srgbClr val="59616B"/>
@@ -11944,6 +12054,7 @@
           <a:lstStyle xmlns:a="http://schemas.openxmlformats.org/drawingml/2006/main"/>
           <a:p xmlns:a="http://schemas.openxmlformats.org/drawingml/2006/main">
             <a:pPr algn="ctr">
+              <a:buNone/>
               <a:defRPr sz="1800" b="0">
                 <a:solidFill>
                   <a:srgbClr val="000000"/>
@@ -12029,6 +12140,7 @@
           <a:lstStyle xmlns:a="http://schemas.openxmlformats.org/drawingml/2006/main"/>
           <a:p xmlns:a="http://schemas.openxmlformats.org/drawingml/2006/main">
             <a:pPr algn="l">
+              <a:buNone/>
               <a:defRPr sz="1200" b="1">
                 <a:solidFill>
                   <a:srgbClr val="59616B"/>
@@ -12085,6 +12197,7 @@
           <a:lstStyle xmlns:a="http://schemas.openxmlformats.org/drawingml/2006/main"/>
           <a:p xmlns:a="http://schemas.openxmlformats.org/drawingml/2006/main">
             <a:pPr algn="l">
+              <a:buNone/>
               <a:defRPr sz="3600" b="1">
                 <a:solidFill>
                   <a:srgbClr val="000000"/>
@@ -12141,6 +12254,7 @@
           <a:lstStyle xmlns:a="http://schemas.openxmlformats.org/drawingml/2006/main"/>
           <a:p xmlns:a="http://schemas.openxmlformats.org/drawingml/2006/main">
             <a:pPr algn="r">
+              <a:buNone/>
               <a:defRPr sz="1050" b="0">
                 <a:solidFill>
                   <a:srgbClr val="59616B"/>
@@ -12197,6 +12311,7 @@
           <a:lstStyle xmlns:a="http://schemas.openxmlformats.org/drawingml/2006/main"/>
           <a:p xmlns:a="http://schemas.openxmlformats.org/drawingml/2006/main">
             <a:pPr algn="l">
+              <a:buNone/>
               <a:defRPr sz="1650" b="0">
                 <a:solidFill>
                   <a:srgbClr val="59616B"/>
@@ -12222,7 +12337,7 @@
       </p:sp>
       <p:graphicFrame>
         <p:nvGraphicFramePr>
-          <p:cNvPr id="10" name=""/>
+          <p:cNvPr id="12" name=""/>
           <p:cNvGraphicFramePr/>
           <p:nvPr/>
         </p:nvGraphicFramePr>
@@ -12939,6 +13054,7 @@
           <a:lstStyle xmlns:a="http://schemas.openxmlformats.org/drawingml/2006/main"/>
           <a:p xmlns:a="http://schemas.openxmlformats.org/drawingml/2006/main">
             <a:pPr algn="l">
+              <a:buNone/>
               <a:defRPr sz="1200" b="1">
                 <a:solidFill>
                   <a:srgbClr val="59616B"/>
@@ -12995,6 +13111,7 @@
           <a:lstStyle xmlns:a="http://schemas.openxmlformats.org/drawingml/2006/main"/>
           <a:p xmlns:a="http://schemas.openxmlformats.org/drawingml/2006/main">
             <a:pPr algn="l">
+              <a:buNone/>
               <a:defRPr sz="3600" b="1">
                 <a:solidFill>
                   <a:srgbClr val="000000"/>
@@ -13051,6 +13168,7 @@
           <a:lstStyle xmlns:a="http://schemas.openxmlformats.org/drawingml/2006/main"/>
           <a:p xmlns:a="http://schemas.openxmlformats.org/drawingml/2006/main">
             <a:pPr algn="r">
+              <a:buNone/>
               <a:defRPr sz="1050" b="0">
                 <a:solidFill>
                   <a:srgbClr val="59616B"/>
@@ -13171,6 +13289,7 @@
           <a:lstStyle xmlns:a="http://schemas.openxmlformats.org/drawingml/2006/main"/>
           <a:p xmlns:a="http://schemas.openxmlformats.org/drawingml/2006/main">
             <a:pPr algn="l">
+              <a:buNone/>
               <a:defRPr sz="2400" b="1">
                 <a:solidFill>
                   <a:srgbClr val="000000"/>
@@ -13227,6 +13346,7 @@
           <a:lstStyle xmlns:a="http://schemas.openxmlformats.org/drawingml/2006/main"/>
           <a:p xmlns:a="http://schemas.openxmlformats.org/drawingml/2006/main">
             <a:pPr algn="l">
+              <a:buNone/>
               <a:defRPr sz="1800" b="1">
                 <a:solidFill>
                   <a:srgbClr val="B8BCC4"/>
@@ -13283,6 +13403,7 @@
           <a:lstStyle xmlns:a="http://schemas.openxmlformats.org/drawingml/2006/main"/>
           <a:p xmlns:a="http://schemas.openxmlformats.org/drawingml/2006/main">
             <a:pPr algn="l">
+              <a:buNone/>
               <a:defRPr sz="1725" b="0">
                 <a:solidFill>
                   <a:srgbClr val="59616B"/>
@@ -13306,6 +13427,7 @@
           </a:p>
           <a:p xmlns:a="http://schemas.openxmlformats.org/drawingml/2006/main">
             <a:pPr algn="l">
+              <a:buNone/>
               <a:defRPr sz="1725" b="0">
                 <a:solidFill>
                   <a:srgbClr val="59616B"/>
@@ -13329,6 +13451,7 @@
           </a:p>
           <a:p xmlns:a="http://schemas.openxmlformats.org/drawingml/2006/main">
             <a:pPr algn="l">
+              <a:buNone/>
               <a:defRPr sz="1725" b="0">
                 <a:solidFill>
                   <a:srgbClr val="59616B"/>
@@ -13449,6 +13572,7 @@
           <a:lstStyle xmlns:a="http://schemas.openxmlformats.org/drawingml/2006/main"/>
           <a:p xmlns:a="http://schemas.openxmlformats.org/drawingml/2006/main">
             <a:pPr algn="l">
+              <a:buNone/>
               <a:defRPr sz="2400" b="1">
                 <a:solidFill>
                   <a:srgbClr val="000000"/>
@@ -13505,6 +13629,7 @@
           <a:lstStyle xmlns:a="http://schemas.openxmlformats.org/drawingml/2006/main"/>
           <a:p xmlns:a="http://schemas.openxmlformats.org/drawingml/2006/main">
             <a:pPr algn="l">
+              <a:buNone/>
               <a:defRPr sz="1800" b="1">
                 <a:solidFill>
                   <a:srgbClr val="7B2CBF"/>
@@ -13561,6 +13686,7 @@
           <a:lstStyle xmlns:a="http://schemas.openxmlformats.org/drawingml/2006/main"/>
           <a:p xmlns:a="http://schemas.openxmlformats.org/drawingml/2006/main">
             <a:pPr algn="l">
+              <a:buNone/>
               <a:defRPr sz="1725" b="0">
                 <a:solidFill>
                   <a:srgbClr val="59616B"/>
@@ -13584,6 +13710,7 @@
           </a:p>
           <a:p xmlns:a="http://schemas.openxmlformats.org/drawingml/2006/main">
             <a:pPr algn="l">
+              <a:buNone/>
               <a:defRPr sz="1725" b="0">
                 <a:solidFill>
                   <a:srgbClr val="59616B"/>
@@ -13607,6 +13734,7 @@
           </a:p>
           <a:p xmlns:a="http://schemas.openxmlformats.org/drawingml/2006/main">
             <a:pPr algn="l">
+              <a:buNone/>
               <a:defRPr sz="1725" b="0">
                 <a:solidFill>
                   <a:srgbClr val="59616B"/>
@@ -13727,6 +13855,7 @@
           <a:lstStyle xmlns:a="http://schemas.openxmlformats.org/drawingml/2006/main"/>
           <a:p xmlns:a="http://schemas.openxmlformats.org/drawingml/2006/main">
             <a:pPr algn="l">
+              <a:buNone/>
               <a:defRPr sz="2400" b="1">
                 <a:solidFill>
                   <a:srgbClr val="000000"/>
@@ -13783,6 +13912,7 @@
           <a:lstStyle xmlns:a="http://schemas.openxmlformats.org/drawingml/2006/main"/>
           <a:p xmlns:a="http://schemas.openxmlformats.org/drawingml/2006/main">
             <a:pPr algn="l">
+              <a:buNone/>
               <a:defRPr sz="1800" b="1">
                 <a:solidFill>
                   <a:srgbClr val="3D8DFF"/>
@@ -13839,6 +13969,7 @@
           <a:lstStyle xmlns:a="http://schemas.openxmlformats.org/drawingml/2006/main"/>
           <a:p xmlns:a="http://schemas.openxmlformats.org/drawingml/2006/main">
             <a:pPr algn="l">
+              <a:buNone/>
               <a:defRPr sz="1725" b="0">
                 <a:solidFill>
                   <a:srgbClr val="59616B"/>
@@ -13862,6 +13993,7 @@
           </a:p>
           <a:p xmlns:a="http://schemas.openxmlformats.org/drawingml/2006/main">
             <a:pPr algn="l">
+              <a:buNone/>
               <a:defRPr sz="1725" b="0">
                 <a:solidFill>
                   <a:srgbClr val="59616B"/>
@@ -13885,6 +14017,7 @@
           </a:p>
           <a:p xmlns:a="http://schemas.openxmlformats.org/drawingml/2006/main">
             <a:pPr algn="l">
+              <a:buNone/>
               <a:defRPr sz="1725" b="0">
                 <a:solidFill>
                   <a:srgbClr val="59616B"/>
@@ -13941,6 +14074,7 @@
           <a:lstStyle xmlns:a="http://schemas.openxmlformats.org/drawingml/2006/main"/>
           <a:p xmlns:a="http://schemas.openxmlformats.org/drawingml/2006/main">
             <a:pPr algn="ctr">
+              <a:buNone/>
               <a:defRPr sz="2100" b="1">
                 <a:solidFill>
                   <a:srgbClr val="000000"/>
@@ -14026,6 +14160,7 @@
           <a:lstStyle xmlns:a="http://schemas.openxmlformats.org/drawingml/2006/main"/>
           <a:p xmlns:a="http://schemas.openxmlformats.org/drawingml/2006/main">
             <a:pPr algn="l">
+              <a:buNone/>
               <a:defRPr sz="1200" b="1">
                 <a:solidFill>
                   <a:srgbClr val="59616B"/>
@@ -14082,6 +14217,7 @@
           <a:lstStyle xmlns:a="http://schemas.openxmlformats.org/drawingml/2006/main"/>
           <a:p xmlns:a="http://schemas.openxmlformats.org/drawingml/2006/main">
             <a:pPr algn="l">
+              <a:buNone/>
               <a:defRPr sz="3600" b="1">
                 <a:solidFill>
                   <a:srgbClr val="000000"/>
@@ -14138,6 +14274,7 @@
           <a:lstStyle xmlns:a="http://schemas.openxmlformats.org/drawingml/2006/main"/>
           <a:p xmlns:a="http://schemas.openxmlformats.org/drawingml/2006/main">
             <a:pPr algn="r">
+              <a:buNone/>
               <a:defRPr sz="1050" b="0">
                 <a:solidFill>
                   <a:srgbClr val="59616B"/>
@@ -14258,6 +14395,7 @@
           <a:lstStyle xmlns:a="http://schemas.openxmlformats.org/drawingml/2006/main"/>
           <a:p xmlns:a="http://schemas.openxmlformats.org/drawingml/2006/main">
             <a:pPr algn="ctr">
+              <a:buNone/>
               <a:defRPr sz="2250" b="1">
                 <a:solidFill>
                   <a:srgbClr val="000000"/>
@@ -14314,6 +14452,7 @@
           <a:lstStyle xmlns:a="http://schemas.openxmlformats.org/drawingml/2006/main"/>
           <a:p xmlns:a="http://schemas.openxmlformats.org/drawingml/2006/main">
             <a:pPr algn="ctr">
+              <a:buNone/>
               <a:defRPr sz="2025" b="1">
                 <a:solidFill>
                   <a:srgbClr val="000000"/>
@@ -14370,6 +14509,7 @@
           <a:lstStyle xmlns:a="http://schemas.openxmlformats.org/drawingml/2006/main"/>
           <a:p xmlns:a="http://schemas.openxmlformats.org/drawingml/2006/main">
             <a:pPr algn="ctr">
+              <a:buNone/>
               <a:defRPr sz="1650" b="0">
                 <a:solidFill>
                   <a:srgbClr val="59616B"/>
@@ -14393,6 +14533,7 @@
           </a:p>
           <a:p xmlns:a="http://schemas.openxmlformats.org/drawingml/2006/main">
             <a:pPr algn="ctr">
+              <a:buNone/>
               <a:defRPr sz="1650" b="0">
                 <a:solidFill>
                   <a:srgbClr val="59616B"/>
@@ -14482,6 +14623,7 @@
           <a:lstStyle xmlns:a="http://schemas.openxmlformats.org/drawingml/2006/main"/>
           <a:p xmlns:a="http://schemas.openxmlformats.org/drawingml/2006/main">
             <a:pPr algn="ctr">
+              <a:buNone/>
               <a:defRPr sz="2250" b="1">
                 <a:solidFill>
                   <a:srgbClr val="000000"/>
@@ -14538,6 +14680,7 @@
           <a:lstStyle xmlns:a="http://schemas.openxmlformats.org/drawingml/2006/main"/>
           <a:p xmlns:a="http://schemas.openxmlformats.org/drawingml/2006/main">
             <a:pPr algn="ctr">
+              <a:buNone/>
               <a:defRPr sz="2025" b="1">
                 <a:solidFill>
                   <a:srgbClr val="000000"/>
@@ -14594,6 +14737,7 @@
           <a:lstStyle xmlns:a="http://schemas.openxmlformats.org/drawingml/2006/main"/>
           <a:p xmlns:a="http://schemas.openxmlformats.org/drawingml/2006/main">
             <a:pPr algn="ctr">
+              <a:buNone/>
               <a:defRPr sz="1650" b="0">
                 <a:solidFill>
                   <a:srgbClr val="59616B"/>
@@ -14617,6 +14761,7 @@
           </a:p>
           <a:p xmlns:a="http://schemas.openxmlformats.org/drawingml/2006/main">
             <a:pPr algn="ctr">
+              <a:buNone/>
               <a:defRPr sz="1650" b="0">
                 <a:solidFill>
                   <a:srgbClr val="59616B"/>
@@ -14706,6 +14851,7 @@
           <a:lstStyle xmlns:a="http://schemas.openxmlformats.org/drawingml/2006/main"/>
           <a:p xmlns:a="http://schemas.openxmlformats.org/drawingml/2006/main">
             <a:pPr algn="ctr">
+              <a:buNone/>
               <a:defRPr sz="2250" b="1">
                 <a:solidFill>
                   <a:srgbClr val="000000"/>
@@ -14762,6 +14908,7 @@
           <a:lstStyle xmlns:a="http://schemas.openxmlformats.org/drawingml/2006/main"/>
           <a:p xmlns:a="http://schemas.openxmlformats.org/drawingml/2006/main">
             <a:pPr algn="ctr">
+              <a:buNone/>
               <a:defRPr sz="2025" b="1">
                 <a:solidFill>
                   <a:srgbClr val="000000"/>
@@ -14818,6 +14965,7 @@
           <a:lstStyle xmlns:a="http://schemas.openxmlformats.org/drawingml/2006/main"/>
           <a:p xmlns:a="http://schemas.openxmlformats.org/drawingml/2006/main">
             <a:pPr algn="ctr">
+              <a:buNone/>
               <a:defRPr sz="1650" b="0">
                 <a:solidFill>
                   <a:srgbClr val="59616B"/>
@@ -14841,6 +14989,7 @@
           </a:p>
           <a:p xmlns:a="http://schemas.openxmlformats.org/drawingml/2006/main">
             <a:pPr algn="ctr">
+              <a:buNone/>
               <a:defRPr sz="1650" b="0">
                 <a:solidFill>
                   <a:srgbClr val="59616B"/>
@@ -14930,6 +15079,7 @@
           <a:lstStyle xmlns:a="http://schemas.openxmlformats.org/drawingml/2006/main"/>
           <a:p xmlns:a="http://schemas.openxmlformats.org/drawingml/2006/main">
             <a:pPr algn="ctr">
+              <a:buNone/>
               <a:defRPr sz="2250" b="1">
                 <a:solidFill>
                   <a:srgbClr val="FFFFFF"/>
@@ -14986,6 +15136,7 @@
           <a:lstStyle xmlns:a="http://schemas.openxmlformats.org/drawingml/2006/main"/>
           <a:p xmlns:a="http://schemas.openxmlformats.org/drawingml/2006/main">
             <a:pPr algn="ctr">
+              <a:buNone/>
               <a:defRPr sz="2025" b="1">
                 <a:solidFill>
                   <a:srgbClr val="000000"/>
@@ -15042,6 +15193,7 @@
           <a:lstStyle xmlns:a="http://schemas.openxmlformats.org/drawingml/2006/main"/>
           <a:p xmlns:a="http://schemas.openxmlformats.org/drawingml/2006/main">
             <a:pPr algn="ctr">
+              <a:buNone/>
               <a:defRPr sz="1650" b="0">
                 <a:solidFill>
                   <a:srgbClr val="59616B"/>
@@ -15065,6 +15217,7 @@
           </a:p>
           <a:p xmlns:a="http://schemas.openxmlformats.org/drawingml/2006/main">
             <a:pPr algn="ctr">
+              <a:buNone/>
               <a:defRPr sz="1650" b="0">
                 <a:solidFill>
                   <a:srgbClr val="59616B"/>
@@ -15121,6 +15274,7 @@
           <a:lstStyle xmlns:a="http://schemas.openxmlformats.org/drawingml/2006/main"/>
           <a:p xmlns:a="http://schemas.openxmlformats.org/drawingml/2006/main">
             <a:pPr algn="l">
+              <a:buNone/>
               <a:defRPr sz="1875" b="1">
                 <a:solidFill>
                   <a:srgbClr val="000000"/>
@@ -15177,6 +15331,7 @@
           <a:lstStyle xmlns:a="http://schemas.openxmlformats.org/drawingml/2006/main"/>
           <a:p xmlns:a="http://schemas.openxmlformats.org/drawingml/2006/main">
             <a:pPr algn="r">
+              <a:buNone/>
               <a:defRPr sz="3375" b="1">
                 <a:solidFill>
                   <a:srgbClr val="3D8DFF"/>
@@ -15195,7 +15350,7 @@
                 <a:ea typeface="Arial"/>
                 <a:cs typeface="Arial"/>
               </a:rPr>
-              <a:t>0.9424 +/- 0.0009</a:t>
+              <a:t>0.9394 +/- 0.0005</a:t>
             </a:r>
           </a:p>
         </p:txBody>
@@ -15233,6 +15388,7 @@
           <a:lstStyle xmlns:a="http://schemas.openxmlformats.org/drawingml/2006/main"/>
           <a:p xmlns:a="http://schemas.openxmlformats.org/drawingml/2006/main">
             <a:pPr algn="r">
+              <a:buNone/>
               <a:defRPr sz="1575" b="0">
                 <a:solidFill>
                   <a:srgbClr val="59616B"/>

</xml_diff>